<commit_message>
Update presentation: human executive cold theme, School of Engineering, Full Stack Dev - Java
</commit_message>
<xml_diff>
--- a/GateSync_Project_Presentation.pptx
+++ b/GateSync_Project_Presentation.pptx
@@ -1836,7 +1836,7 @@
     <p:bg>
       <p:bgPr>
         <a:solidFill>
-          <a:srgbClr val="0B1329"/>
+          <a:srgbClr val="F8FAFC"/>
         </a:solidFill>
       </p:bgPr>
     </p:bg>
@@ -1869,11 +1869,11 @@
             <a:avLst/>
           </a:prstGeom>
           <a:solidFill>
-            <a:srgbClr val="38BDF8"/>
+            <a:srgbClr val="1E40AF"/>
           </a:solidFill>
           <a:ln w="12700">
             <a:solidFill>
-              <a:srgbClr val="38BDF8"/>
+              <a:srgbClr val="1E40AF"/>
             </a:solidFill>
             <a:prstDash val="solid"/>
           </a:ln>
@@ -1887,18 +1887,18 @@
         </p:nvSpPr>
         <p:spPr>
           <a:xfrm>
-            <a:off x="548640" y="320040"/>
-            <a:ext cx="4206240" cy="292608"/>
+            <a:off x="548640" y="329184"/>
+            <a:ext cx="45720" cy="201168"/>
           </a:xfrm>
           <a:prstGeom prst="rect">
             <a:avLst/>
           </a:prstGeom>
           <a:solidFill>
-            <a:srgbClr val="112240"/>
+            <a:srgbClr val="1E40AF"/>
           </a:solidFill>
           <a:ln w="12700">
             <a:solidFill>
-              <a:srgbClr val="233554"/>
+              <a:srgbClr val="1E40AF"/>
             </a:solidFill>
             <a:prstDash val="solid"/>
           </a:ln>
@@ -1912,26 +1912,26 @@
         </p:nvSpPr>
         <p:spPr>
           <a:xfrm>
-            <a:off x="685800" y="365760"/>
-            <a:ext cx="3931920" cy="201168"/>
-          </a:xfrm>
-          <a:prstGeom prst="rect">
-            <a:avLst/>
-          </a:prstGeom>
-          <a:noFill/>
-          <a:ln/>
-        </p:spPr>
-        <p:txBody>
-          <a:bodyPr wrap="square" rtlCol="0" anchor="ctr"/>
-          <a:lstStyle/>
-          <a:p>
-            <a:pPr indent="0" marL="0">
-              <a:buNone/>
-            </a:pPr>
-            <a:r>
-              <a:rPr lang="en-US" sz="950" b="1" dirty="0">
-                <a:solidFill>
-                  <a:srgbClr val="38BDF8"/>
+            <a:off x="658368" y="329184"/>
+            <a:ext cx="5486400" cy="219456"/>
+          </a:xfrm>
+          <a:prstGeom prst="rect">
+            <a:avLst/>
+          </a:prstGeom>
+          <a:noFill/>
+          <a:ln/>
+        </p:spPr>
+        <p:txBody>
+          <a:bodyPr wrap="square" rtlCol="0" anchor="ctr"/>
+          <a:lstStyle/>
+          <a:p>
+            <a:pPr indent="0" marL="0">
+              <a:buNone/>
+            </a:pPr>
+            <a:r>
+              <a:rPr lang="en-US" sz="1050" b="1" dirty="0">
+                <a:solidFill>
+                  <a:srgbClr val="0F2942"/>
                 </a:solidFill>
                 <a:latin typeface="Calibri" pitchFamily="34" charset="0"/>
                 <a:ea typeface="Calibri" pitchFamily="34" charset="-122"/>
@@ -1939,7 +1939,7 @@
               </a:rPr>
               <a:t>P. P. SAVANI UNIVERSITY  •  SCHOOL OF ENGINEERING</a:t>
             </a:r>
-            <a:endParaRPr lang="en-US" sz="950" dirty="0"/>
+            <a:endParaRPr lang="en-US" sz="1050" dirty="0"/>
           </a:p>
         </p:txBody>
       </p:sp>
@@ -1975,7 +1975,7 @@
         </p:nvSpPr>
         <p:spPr>
           <a:xfrm>
-            <a:off x="548640" y="777240"/>
+            <a:off x="548640" y="731520"/>
             <a:ext cx="8046720" cy="594360"/>
           </a:xfrm>
           <a:prstGeom prst="rect">
@@ -1994,7 +1994,7 @@
             <a:r>
               <a:rPr lang="en-US" sz="4000" b="1" dirty="0">
                 <a:solidFill>
-                  <a:srgbClr val="FFFFFF"/>
+                  <a:srgbClr val="0F2942"/>
                 </a:solidFill>
                 <a:latin typeface="Calibri" pitchFamily="34" charset="0"/>
                 <a:ea typeface="Calibri" pitchFamily="34" charset="-122"/>
@@ -2014,7 +2014,7 @@
         </p:nvSpPr>
         <p:spPr>
           <a:xfrm>
-            <a:off x="548640" y="1325880"/>
+            <a:off x="548640" y="1298448"/>
             <a:ext cx="8046720" cy="274320"/>
           </a:xfrm>
           <a:prstGeom prst="rect">
@@ -2033,7 +2033,7 @@
             <a:r>
               <a:rPr lang="en-US" sz="1500" b="1" dirty="0">
                 <a:solidFill>
-                  <a:srgbClr val="38BDF8"/>
+                  <a:srgbClr val="1E40AF"/>
                 </a:solidFill>
                 <a:latin typeface="Calibri" pitchFamily="34" charset="0"/>
                 <a:ea typeface="Calibri" pitchFamily="34" charset="-122"/>
@@ -2053,7 +2053,7 @@
         </p:nvSpPr>
         <p:spPr>
           <a:xfrm>
-            <a:off x="548640" y="1645920"/>
+            <a:off x="548640" y="1609344"/>
             <a:ext cx="8046720" cy="502920"/>
           </a:xfrm>
           <a:prstGeom prst="rect">
@@ -2072,13 +2072,13 @@
             <a:r>
               <a:rPr lang="en-US" sz="1000" dirty="0">
                 <a:solidFill>
-                  <a:srgbClr val="CBD5E1"/>
-                </a:solidFill>
-                <a:latin typeface="Calibri" pitchFamily="34" charset="0"/>
-                <a:ea typeface="Calibri" pitchFamily="34" charset="-122"/>
-                <a:cs typeface="Calibri" pitchFamily="34" charset="-120"/>
-              </a:rPr>
-              <a:t>A full-stack Progressive Web Application (PWA) designed to modernize residential community security operations. Replaces manual paper registers with real-time mobile push notifications for residents, 1-tap courier clearance, pre-approved digital QR guest passes, and society maintenance billing.</a:t>
+                  <a:srgbClr val="334155"/>
+                </a:solidFill>
+                <a:latin typeface="Calibri" pitchFamily="34" charset="0"/>
+                <a:ea typeface="Calibri" pitchFamily="34" charset="-122"/>
+                <a:cs typeface="Calibri" pitchFamily="34" charset="-120"/>
+              </a:rPr>
+              <a:t>A full-stack Progressive Web Application (PWA) designed to modernize residential community security operations. Replaces manual paper registers with real-time mobile push notifications for residents, 1-tap courier clearance, pre-approved digital QR guest passes, and society maintenance accounting.</a:t>
             </a:r>
             <a:endParaRPr lang="en-US" sz="1000" dirty="0"/>
           </a:p>
@@ -2092,18 +2092,18 @@
         </p:nvSpPr>
         <p:spPr>
           <a:xfrm>
-            <a:off x="548640" y="2286000"/>
-            <a:ext cx="8046720" cy="2240280"/>
+            <a:off x="548640" y="2240280"/>
+            <a:ext cx="8046720" cy="2286000"/>
           </a:xfrm>
           <a:prstGeom prst="rect">
             <a:avLst/>
           </a:prstGeom>
           <a:solidFill>
-            <a:srgbClr val="162238"/>
+            <a:srgbClr val="FFFFFF"/>
           </a:solidFill>
           <a:ln w="12700">
             <a:solidFill>
-              <a:srgbClr val="233554"/>
+              <a:srgbClr val="E2E8F0"/>
             </a:solidFill>
             <a:prstDash val="solid"/>
           </a:ln>
@@ -2117,18 +2117,18 @@
         </p:nvSpPr>
         <p:spPr>
           <a:xfrm>
-            <a:off x="548640" y="2286000"/>
-            <a:ext cx="73152" cy="2240280"/>
+            <a:off x="548640" y="2240280"/>
+            <a:ext cx="73152" cy="2286000"/>
           </a:xfrm>
           <a:prstGeom prst="rect">
             <a:avLst/>
           </a:prstGeom>
           <a:solidFill>
-            <a:srgbClr val="38BDF8"/>
+            <a:srgbClr val="0F2942"/>
           </a:solidFill>
           <a:ln w="12700">
             <a:solidFill>
-              <a:srgbClr val="38BDF8"/>
+              <a:srgbClr val="0F2942"/>
             </a:solidFill>
             <a:prstDash val="solid"/>
           </a:ln>
@@ -2142,8 +2142,8 @@
         </p:nvSpPr>
         <p:spPr>
           <a:xfrm>
-            <a:off x="777240" y="2423160"/>
-            <a:ext cx="3840480" cy="1965960"/>
+            <a:off x="777240" y="2377440"/>
+            <a:ext cx="3840480" cy="2011680"/>
           </a:xfrm>
           <a:prstGeom prst="rect">
             <a:avLst/>
@@ -2161,7 +2161,7 @@
             <a:r>
               <a:rPr lang="en-US" sz="850" b="1" dirty="0">
                 <a:solidFill>
-                  <a:srgbClr val="94A3B8"/>
+                  <a:srgbClr val="64748B"/>
                 </a:solidFill>
                 <a:latin typeface="Calibri" pitchFamily="34" charset="0"/>
                 <a:ea typeface="Calibri" pitchFamily="34" charset="-122"/>
@@ -2176,7 +2176,7 @@
             <a:r>
               <a:rPr lang="en-US" sz="1600" b="1" dirty="0">
                 <a:solidFill>
-                  <a:srgbClr val="FFFFFF"/>
+                  <a:srgbClr val="0F172A"/>
                 </a:solidFill>
                 <a:latin typeface="Calibri" pitchFamily="34" charset="0"/>
                 <a:ea typeface="Calibri" pitchFamily="34" charset="-122"/>
@@ -2191,7 +2191,7 @@
             <a:r>
               <a:rPr lang="en-US" sz="850" b="1" dirty="0">
                 <a:solidFill>
-                  <a:srgbClr val="94A3B8"/>
+                  <a:srgbClr val="64748B"/>
                 </a:solidFill>
                 <a:latin typeface="Calibri" pitchFamily="34" charset="0"/>
                 <a:ea typeface="Calibri" pitchFamily="34" charset="-122"/>
@@ -2206,7 +2206,7 @@
             <a:r>
               <a:rPr lang="en-US" sz="1400" b="1" dirty="0">
                 <a:solidFill>
-                  <a:srgbClr val="38BDF8"/>
+                  <a:srgbClr val="1E40AF"/>
                 </a:solidFill>
                 <a:latin typeface="Calibri" pitchFamily="34" charset="0"/>
                 <a:ea typeface="Calibri" pitchFamily="34" charset="-122"/>
@@ -2221,7 +2221,7 @@
             <a:r>
               <a:rPr lang="en-US" sz="850" b="1" dirty="0">
                 <a:solidFill>
-                  <a:srgbClr val="94A3B8"/>
+                  <a:srgbClr val="64748B"/>
                 </a:solidFill>
                 <a:latin typeface="Calibri" pitchFamily="34" charset="0"/>
                 <a:ea typeface="Calibri" pitchFamily="34" charset="-122"/>
@@ -2236,7 +2236,7 @@
             <a:r>
               <a:rPr lang="en-US" sz="1100" b="1" dirty="0">
                 <a:solidFill>
-                  <a:srgbClr val="FFFFFF"/>
+                  <a:srgbClr val="0F172A"/>
                 </a:solidFill>
                 <a:latin typeface="Calibri" pitchFamily="34" charset="0"/>
                 <a:ea typeface="Calibri" pitchFamily="34" charset="-122"/>
@@ -2251,7 +2251,7 @@
             <a:r>
               <a:rPr lang="en-US" sz="1000" dirty="0">
                 <a:solidFill>
-                  <a:srgbClr val="CBD5E1"/>
+                  <a:srgbClr val="334155"/>
                 </a:solidFill>
                 <a:latin typeface="Calibri" pitchFamily="34" charset="0"/>
                 <a:ea typeface="Calibri" pitchFamily="34" charset="-122"/>
@@ -2271,8 +2271,8 @@
         </p:nvSpPr>
         <p:spPr>
           <a:xfrm>
-            <a:off x="4846320" y="2423160"/>
-            <a:ext cx="3566160" cy="1965960"/>
+            <a:off x="4846320" y="2377440"/>
+            <a:ext cx="3566160" cy="2011680"/>
           </a:xfrm>
           <a:prstGeom prst="rect">
             <a:avLst/>
@@ -2290,7 +2290,7 @@
             <a:r>
               <a:rPr lang="en-US" sz="850" b="1" dirty="0">
                 <a:solidFill>
-                  <a:srgbClr val="94A3B8"/>
+                  <a:srgbClr val="64748B"/>
                 </a:solidFill>
                 <a:latin typeface="Calibri" pitchFamily="34" charset="0"/>
                 <a:ea typeface="Calibri" pitchFamily="34" charset="-122"/>
@@ -2305,7 +2305,7 @@
             <a:r>
               <a:rPr lang="en-US" sz="1300" b="1" dirty="0">
                 <a:solidFill>
-                  <a:srgbClr val="FFFFFF"/>
+                  <a:srgbClr val="0F172A"/>
                 </a:solidFill>
                 <a:latin typeface="Calibri" pitchFamily="34" charset="0"/>
                 <a:ea typeface="Calibri" pitchFamily="34" charset="-122"/>
@@ -2320,7 +2320,7 @@
             <a:r>
               <a:rPr lang="en-US" sz="950" dirty="0">
                 <a:solidFill>
-                  <a:srgbClr val="CBD5E1"/>
+                  <a:srgbClr val="334155"/>
                 </a:solidFill>
                 <a:latin typeface="Calibri" pitchFamily="34" charset="0"/>
                 <a:ea typeface="Calibri" pitchFamily="34" charset="-122"/>
@@ -2335,7 +2335,7 @@
             <a:r>
               <a:rPr lang="en-US" sz="850" b="1" dirty="0">
                 <a:solidFill>
-                  <a:srgbClr val="94A3B8"/>
+                  <a:srgbClr val="64748B"/>
                 </a:solidFill>
                 <a:latin typeface="Calibri" pitchFamily="34" charset="0"/>
                 <a:ea typeface="Calibri" pitchFamily="34" charset="-122"/>
@@ -2350,7 +2350,7 @@
             <a:r>
               <a:rPr lang="en-US" sz="1200" b="1" dirty="0">
                 <a:solidFill>
-                  <a:srgbClr val="FFFFFF"/>
+                  <a:srgbClr val="0F172A"/>
                 </a:solidFill>
                 <a:latin typeface="Calibri" pitchFamily="34" charset="0"/>
                 <a:ea typeface="Calibri" pitchFamily="34" charset="-122"/>
@@ -2365,7 +2365,7 @@
             <a:r>
               <a:rPr lang="en-US" sz="1000" dirty="0">
                 <a:solidFill>
-                  <a:srgbClr val="CBD5E1"/>
+                  <a:srgbClr val="334155"/>
                 </a:solidFill>
                 <a:latin typeface="Calibri" pitchFamily="34" charset="0"/>
                 <a:ea typeface="Calibri" pitchFamily="34" charset="-122"/>
@@ -2380,7 +2380,7 @@
             <a:r>
               <a:rPr lang="en-US" sz="850" b="1" dirty="0">
                 <a:solidFill>
-                  <a:srgbClr val="94A3B8"/>
+                  <a:srgbClr val="64748B"/>
                 </a:solidFill>
                 <a:latin typeface="Calibri" pitchFamily="34" charset="0"/>
                 <a:ea typeface="Calibri" pitchFamily="34" charset="-122"/>
@@ -2395,7 +2395,7 @@
             <a:r>
               <a:rPr lang="en-US" sz="1300" b="1" dirty="0">
                 <a:solidFill>
-                  <a:srgbClr val="10B981"/>
+                  <a:srgbClr val="1E40AF"/>
                 </a:solidFill>
                 <a:latin typeface="Calibri" pitchFamily="34" charset="0"/>
                 <a:ea typeface="Calibri" pitchFamily="34" charset="-122"/>
@@ -2410,7 +2410,7 @@
             <a:r>
               <a:rPr lang="en-US" sz="950" dirty="0">
                 <a:solidFill>
-                  <a:srgbClr val="CBD5E1"/>
+                  <a:srgbClr val="334155"/>
                 </a:solidFill>
                 <a:latin typeface="Calibri" pitchFamily="34" charset="0"/>
                 <a:ea typeface="Calibri" pitchFamily="34" charset="-122"/>
@@ -2436,7 +2436,7 @@
     <p:bg>
       <p:bgPr>
         <a:solidFill>
-          <a:srgbClr val="0B1329"/>
+          <a:srgbClr val="F8FAFC"/>
         </a:solidFill>
       </p:bgPr>
     </p:bg>
@@ -2469,11 +2469,11 @@
             <a:avLst/>
           </a:prstGeom>
           <a:solidFill>
-            <a:srgbClr val="38BDF8"/>
+            <a:srgbClr val="1E40AF"/>
           </a:solidFill>
           <a:ln w="12700">
             <a:solidFill>
-              <a:srgbClr val="38BDF8"/>
+              <a:srgbClr val="1E40AF"/>
             </a:solidFill>
             <a:prstDash val="solid"/>
           </a:ln>
@@ -2487,7 +2487,7 @@
         </p:nvSpPr>
         <p:spPr>
           <a:xfrm>
-            <a:off x="548640" y="237744"/>
+            <a:off x="548640" y="219456"/>
             <a:ext cx="5486400" cy="201168"/>
           </a:xfrm>
           <a:prstGeom prst="rect">
@@ -2504,17 +2504,17 @@
               <a:buNone/>
             </a:pPr>
             <a:r>
-              <a:rPr lang="en-US" sz="900" b="1" dirty="0">
-                <a:solidFill>
-                  <a:srgbClr val="38BDF8"/>
-                </a:solidFill>
-                <a:latin typeface="Calibri" pitchFamily="34" charset="0"/>
-                <a:ea typeface="Calibri" pitchFamily="34" charset="-122"/>
-                <a:cs typeface="Calibri" pitchFamily="34" charset="-120"/>
-              </a:rPr>
-              <a:t>GATESYNC  •  09. CLOUD DEVOPS</a:t>
-            </a:r>
-            <a:endParaRPr lang="en-US" sz="900" dirty="0"/>
+              <a:rPr lang="en-US" sz="850" b="1" dirty="0">
+                <a:solidFill>
+                  <a:srgbClr val="1E40AF"/>
+                </a:solidFill>
+                <a:latin typeface="Calibri" pitchFamily="34" charset="0"/>
+                <a:ea typeface="Calibri" pitchFamily="34" charset="-122"/>
+                <a:cs typeface="Calibri" pitchFamily="34" charset="-120"/>
+              </a:rPr>
+              <a:t>SECTION 09  |  CLOUD DEVOPS</a:t>
+            </a:r>
+            <a:endParaRPr lang="en-US" sz="850" dirty="0"/>
           </a:p>
         </p:txBody>
       </p:sp>
@@ -2526,7 +2526,7 @@
         </p:nvSpPr>
         <p:spPr>
           <a:xfrm>
-            <a:off x="548640" y="438912"/>
+            <a:off x="548640" y="420624"/>
             <a:ext cx="8046720" cy="347472"/>
           </a:xfrm>
           <a:prstGeom prst="rect">
@@ -2545,7 +2545,7 @@
             <a:r>
               <a:rPr lang="en-US" sz="1800" b="1" dirty="0">
                 <a:solidFill>
-                  <a:srgbClr val="FFFFFF"/>
+                  <a:srgbClr val="0F2942"/>
                 </a:solidFill>
                 <a:latin typeface="Calibri" pitchFamily="34" charset="0"/>
                 <a:ea typeface="Calibri" pitchFamily="34" charset="-122"/>
@@ -2565,7 +2565,7 @@
         </p:nvSpPr>
         <p:spPr>
           <a:xfrm>
-            <a:off x="548640" y="786384"/>
+            <a:off x="548640" y="768096"/>
             <a:ext cx="8046720" cy="201168"/>
           </a:xfrm>
           <a:prstGeom prst="rect">
@@ -2582,9 +2582,9 @@
               <a:buNone/>
             </a:pPr>
             <a:r>
-              <a:rPr lang="en-US" sz="1000" dirty="0">
-                <a:solidFill>
-                  <a:srgbClr val="94A3B8"/>
+              <a:rPr lang="en-US" sz="950" dirty="0">
+                <a:solidFill>
+                  <a:srgbClr val="64748B"/>
                 </a:solidFill>
                 <a:latin typeface="Calibri" pitchFamily="34" charset="0"/>
                 <a:ea typeface="Calibri" pitchFamily="34" charset="-122"/>
@@ -2592,7 +2592,7 @@
               </a:rPr>
               <a:t>Continuous Delivery, Containerization, and Automated Uptime Monitoring</a:t>
             </a:r>
-            <a:endParaRPr lang="en-US" sz="1000" dirty="0"/>
+            <a:endParaRPr lang="en-US" sz="950" dirty="0"/>
           </a:p>
         </p:txBody>
       </p:sp>
@@ -2604,18 +2604,18 @@
         </p:nvSpPr>
         <p:spPr>
           <a:xfrm>
-            <a:off x="548640" y="1024128"/>
+            <a:off x="548640" y="1005840"/>
             <a:ext cx="8046720" cy="9144"/>
           </a:xfrm>
           <a:prstGeom prst="rect">
             <a:avLst/>
           </a:prstGeom>
           <a:solidFill>
-            <a:srgbClr val="233554"/>
+            <a:srgbClr val="E2E8F0"/>
           </a:solidFill>
           <a:ln w="12700">
             <a:solidFill>
-              <a:srgbClr val="233554"/>
+              <a:srgbClr val="E2E8F0"/>
             </a:solidFill>
             <a:prstDash val="solid"/>
           </a:ln>
@@ -2636,11 +2636,11 @@
             <a:avLst/>
           </a:prstGeom>
           <a:solidFill>
-            <a:srgbClr val="233554"/>
+            <a:srgbClr val="E2E8F0"/>
           </a:solidFill>
           <a:ln w="12700">
             <a:solidFill>
-              <a:srgbClr val="233554"/>
+              <a:srgbClr val="E2E8F0"/>
             </a:solidFill>
             <a:prstDash val="solid"/>
           </a:ln>
@@ -2673,7 +2673,7 @@
             <a:r>
               <a:rPr lang="en-US" sz="850" dirty="0">
                 <a:solidFill>
-                  <a:srgbClr val="94A3B8"/>
+                  <a:srgbClr val="64748B"/>
                 </a:solidFill>
                 <a:latin typeface="Calibri" pitchFamily="34" charset="0"/>
                 <a:ea typeface="Calibri" pitchFamily="34" charset="-122"/>
@@ -2712,7 +2712,7 @@
             <a:r>
               <a:rPr lang="en-US" sz="850" b="1" dirty="0">
                 <a:solidFill>
-                  <a:srgbClr val="38BDF8"/>
+                  <a:srgbClr val="1E40AF"/>
                 </a:solidFill>
                 <a:latin typeface="Calibri" pitchFamily="34" charset="0"/>
                 <a:ea typeface="Calibri" pitchFamily="34" charset="-122"/>
@@ -2739,11 +2739,11 @@
             <a:avLst/>
           </a:prstGeom>
           <a:solidFill>
-            <a:srgbClr val="162238"/>
+            <a:srgbClr val="FFFFFF"/>
           </a:solidFill>
           <a:ln w="12700">
             <a:solidFill>
-              <a:srgbClr val="233554"/>
+              <a:srgbClr val="E2E8F0"/>
             </a:solidFill>
             <a:prstDash val="solid"/>
           </a:ln>
@@ -2764,11 +2764,11 @@
             <a:avLst/>
           </a:prstGeom>
           <a:solidFill>
-            <a:srgbClr val="38BDF8"/>
+            <a:srgbClr val="1E40AF"/>
           </a:solidFill>
           <a:ln w="12700">
             <a:solidFill>
-              <a:srgbClr val="38BDF8"/>
+              <a:srgbClr val="1E40AF"/>
             </a:solidFill>
             <a:prstDash val="solid"/>
           </a:ln>
@@ -2801,7 +2801,7 @@
             <a:r>
               <a:rPr lang="en-US" sz="1000" b="1" dirty="0">
                 <a:solidFill>
-                  <a:srgbClr val="38BDF8"/>
+                  <a:srgbClr val="1E40AF"/>
                 </a:solidFill>
                 <a:latin typeface="Calibri" pitchFamily="34" charset="0"/>
                 <a:ea typeface="Calibri" pitchFamily="34" charset="-122"/>
@@ -2840,7 +2840,7 @@
             <a:r>
               <a:rPr lang="en-US" sz="1200" b="1" dirty="0">
                 <a:solidFill>
-                  <a:srgbClr val="FFFFFF"/>
+                  <a:srgbClr val="0F172A"/>
                 </a:solidFill>
                 <a:latin typeface="Calibri" pitchFamily="34" charset="0"/>
                 <a:ea typeface="Calibri" pitchFamily="34" charset="-122"/>
@@ -2879,7 +2879,7 @@
             <a:r>
               <a:rPr lang="en-US" sz="850" dirty="0">
                 <a:solidFill>
-                  <a:srgbClr val="CBD5E1"/>
+                  <a:srgbClr val="334155"/>
                 </a:solidFill>
                 <a:latin typeface="Calibri" pitchFamily="34" charset="0"/>
                 <a:ea typeface="Calibri" pitchFamily="34" charset="-122"/>
@@ -2902,7 +2902,7 @@
             <a:r>
               <a:rPr lang="en-US" sz="850" dirty="0">
                 <a:solidFill>
-                  <a:srgbClr val="CBD5E1"/>
+                  <a:srgbClr val="334155"/>
                 </a:solidFill>
                 <a:latin typeface="Calibri" pitchFamily="34" charset="0"/>
                 <a:ea typeface="Calibri" pitchFamily="34" charset="-122"/>
@@ -2925,7 +2925,7 @@
             <a:r>
               <a:rPr lang="en-US" sz="850" dirty="0">
                 <a:solidFill>
-                  <a:srgbClr val="CBD5E1"/>
+                  <a:srgbClr val="334155"/>
                 </a:solidFill>
                 <a:latin typeface="Calibri" pitchFamily="34" charset="0"/>
                 <a:ea typeface="Calibri" pitchFamily="34" charset="-122"/>
@@ -2948,7 +2948,7 @@
             <a:r>
               <a:rPr lang="en-US" sz="850" dirty="0">
                 <a:solidFill>
-                  <a:srgbClr val="CBD5E1"/>
+                  <a:srgbClr val="334155"/>
                 </a:solidFill>
                 <a:latin typeface="Calibri" pitchFamily="34" charset="0"/>
                 <a:ea typeface="Calibri" pitchFamily="34" charset="-122"/>
@@ -2975,11 +2975,11 @@
             <a:avLst/>
           </a:prstGeom>
           <a:solidFill>
-            <a:srgbClr val="162238"/>
+            <a:srgbClr val="FFFFFF"/>
           </a:solidFill>
           <a:ln w="12700">
             <a:solidFill>
-              <a:srgbClr val="233554"/>
+              <a:srgbClr val="E2E8F0"/>
             </a:solidFill>
             <a:prstDash val="solid"/>
           </a:ln>
@@ -3000,11 +3000,11 @@
             <a:avLst/>
           </a:prstGeom>
           <a:solidFill>
-            <a:srgbClr val="60A5FA"/>
+            <a:srgbClr val="0F2942"/>
           </a:solidFill>
           <a:ln w="12700">
             <a:solidFill>
-              <a:srgbClr val="60A5FA"/>
+              <a:srgbClr val="0F2942"/>
             </a:solidFill>
             <a:prstDash val="solid"/>
           </a:ln>
@@ -3037,7 +3037,7 @@
             <a:r>
               <a:rPr lang="en-US" sz="1000" b="1" dirty="0">
                 <a:solidFill>
-                  <a:srgbClr val="60A5FA"/>
+                  <a:srgbClr val="0F2942"/>
                 </a:solidFill>
                 <a:latin typeface="Calibri" pitchFamily="34" charset="0"/>
                 <a:ea typeface="Calibri" pitchFamily="34" charset="-122"/>
@@ -3076,7 +3076,7 @@
             <a:r>
               <a:rPr lang="en-US" sz="1200" b="1" dirty="0">
                 <a:solidFill>
-                  <a:srgbClr val="FFFFFF"/>
+                  <a:srgbClr val="0F172A"/>
                 </a:solidFill>
                 <a:latin typeface="Calibri" pitchFamily="34" charset="0"/>
                 <a:ea typeface="Calibri" pitchFamily="34" charset="-122"/>
@@ -3115,7 +3115,7 @@
             <a:r>
               <a:rPr lang="en-US" sz="850" dirty="0">
                 <a:solidFill>
-                  <a:srgbClr val="CBD5E1"/>
+                  <a:srgbClr val="334155"/>
                 </a:solidFill>
                 <a:latin typeface="Calibri" pitchFamily="34" charset="0"/>
                 <a:ea typeface="Calibri" pitchFamily="34" charset="-122"/>
@@ -3138,7 +3138,7 @@
             <a:r>
               <a:rPr lang="en-US" sz="850" dirty="0">
                 <a:solidFill>
-                  <a:srgbClr val="CBD5E1"/>
+                  <a:srgbClr val="334155"/>
                 </a:solidFill>
                 <a:latin typeface="Calibri" pitchFamily="34" charset="0"/>
                 <a:ea typeface="Calibri" pitchFamily="34" charset="-122"/>
@@ -3161,7 +3161,7 @@
             <a:r>
               <a:rPr lang="en-US" sz="850" dirty="0">
                 <a:solidFill>
-                  <a:srgbClr val="CBD5E1"/>
+                  <a:srgbClr val="334155"/>
                 </a:solidFill>
                 <a:latin typeface="Calibri" pitchFamily="34" charset="0"/>
                 <a:ea typeface="Calibri" pitchFamily="34" charset="-122"/>
@@ -3184,7 +3184,7 @@
             <a:r>
               <a:rPr lang="en-US" sz="850" dirty="0">
                 <a:solidFill>
-                  <a:srgbClr val="CBD5E1"/>
+                  <a:srgbClr val="334155"/>
                 </a:solidFill>
                 <a:latin typeface="Calibri" pitchFamily="34" charset="0"/>
                 <a:ea typeface="Calibri" pitchFamily="34" charset="-122"/>
@@ -3211,11 +3211,11 @@
             <a:avLst/>
           </a:prstGeom>
           <a:solidFill>
-            <a:srgbClr val="162238"/>
+            <a:srgbClr val="FFFFFF"/>
           </a:solidFill>
           <a:ln w="12700">
             <a:solidFill>
-              <a:srgbClr val="233554"/>
+              <a:srgbClr val="E2E8F0"/>
             </a:solidFill>
             <a:prstDash val="solid"/>
           </a:ln>
@@ -3236,11 +3236,11 @@
             <a:avLst/>
           </a:prstGeom>
           <a:solidFill>
-            <a:srgbClr val="10B981"/>
+            <a:srgbClr val="16A34A"/>
           </a:solidFill>
           <a:ln w="12700">
             <a:solidFill>
-              <a:srgbClr val="10B981"/>
+              <a:srgbClr val="16A34A"/>
             </a:solidFill>
             <a:prstDash val="solid"/>
           </a:ln>
@@ -3273,7 +3273,7 @@
             <a:r>
               <a:rPr lang="en-US" sz="1000" b="1" dirty="0">
                 <a:solidFill>
-                  <a:srgbClr val="10B981"/>
+                  <a:srgbClr val="16A34A"/>
                 </a:solidFill>
                 <a:latin typeface="Calibri" pitchFamily="34" charset="0"/>
                 <a:ea typeface="Calibri" pitchFamily="34" charset="-122"/>
@@ -3312,7 +3312,7 @@
             <a:r>
               <a:rPr lang="en-US" sz="1200" b="1" dirty="0">
                 <a:solidFill>
-                  <a:srgbClr val="FFFFFF"/>
+                  <a:srgbClr val="0F172A"/>
                 </a:solidFill>
                 <a:latin typeface="Calibri" pitchFamily="34" charset="0"/>
                 <a:ea typeface="Calibri" pitchFamily="34" charset="-122"/>
@@ -3351,7 +3351,7 @@
             <a:r>
               <a:rPr lang="en-US" sz="850" dirty="0">
                 <a:solidFill>
-                  <a:srgbClr val="CBD5E1"/>
+                  <a:srgbClr val="334155"/>
                 </a:solidFill>
                 <a:latin typeface="Calibri" pitchFamily="34" charset="0"/>
                 <a:ea typeface="Calibri" pitchFamily="34" charset="-122"/>
@@ -3374,7 +3374,7 @@
             <a:r>
               <a:rPr lang="en-US" sz="850" dirty="0">
                 <a:solidFill>
-                  <a:srgbClr val="CBD5E1"/>
+                  <a:srgbClr val="334155"/>
                 </a:solidFill>
                 <a:latin typeface="Calibri" pitchFamily="34" charset="0"/>
                 <a:ea typeface="Calibri" pitchFamily="34" charset="-122"/>
@@ -3397,7 +3397,7 @@
             <a:r>
               <a:rPr lang="en-US" sz="850" dirty="0">
                 <a:solidFill>
-                  <a:srgbClr val="CBD5E1"/>
+                  <a:srgbClr val="334155"/>
                 </a:solidFill>
                 <a:latin typeface="Calibri" pitchFamily="34" charset="0"/>
                 <a:ea typeface="Calibri" pitchFamily="34" charset="-122"/>
@@ -3420,7 +3420,7 @@
             <a:r>
               <a:rPr lang="en-US" sz="850" dirty="0">
                 <a:solidFill>
-                  <a:srgbClr val="CBD5E1"/>
+                  <a:srgbClr val="334155"/>
                 </a:solidFill>
                 <a:latin typeface="Calibri" pitchFamily="34" charset="0"/>
                 <a:ea typeface="Calibri" pitchFamily="34" charset="-122"/>
@@ -3446,7 +3446,7 @@
     <p:bg>
       <p:bgPr>
         <a:solidFill>
-          <a:srgbClr val="0B1329"/>
+          <a:srgbClr val="F8FAFC"/>
         </a:solidFill>
       </p:bgPr>
     </p:bg>
@@ -3479,11 +3479,11 @@
             <a:avLst/>
           </a:prstGeom>
           <a:solidFill>
-            <a:srgbClr val="38BDF8"/>
+            <a:srgbClr val="1E40AF"/>
           </a:solidFill>
           <a:ln w="12700">
             <a:solidFill>
-              <a:srgbClr val="38BDF8"/>
+              <a:srgbClr val="1E40AF"/>
             </a:solidFill>
             <a:prstDash val="solid"/>
           </a:ln>
@@ -3497,7 +3497,7 @@
         </p:nvSpPr>
         <p:spPr>
           <a:xfrm>
-            <a:off x="548640" y="237744"/>
+            <a:off x="548640" y="219456"/>
             <a:ext cx="5486400" cy="201168"/>
           </a:xfrm>
           <a:prstGeom prst="rect">
@@ -3514,17 +3514,17 @@
               <a:buNone/>
             </a:pPr>
             <a:r>
-              <a:rPr lang="en-US" sz="900" b="1" dirty="0">
-                <a:solidFill>
-                  <a:srgbClr val="38BDF8"/>
-                </a:solidFill>
-                <a:latin typeface="Calibri" pitchFamily="34" charset="0"/>
-                <a:ea typeface="Calibri" pitchFamily="34" charset="-122"/>
-                <a:cs typeface="Calibri" pitchFamily="34" charset="-120"/>
-              </a:rPr>
-              <a:t>GATESYNC  •  10. VALIDATION &amp; ROADMAP</a:t>
-            </a:r>
-            <a:endParaRPr lang="en-US" sz="900" dirty="0"/>
+              <a:rPr lang="en-US" sz="850" b="1" dirty="0">
+                <a:solidFill>
+                  <a:srgbClr val="1E40AF"/>
+                </a:solidFill>
+                <a:latin typeface="Calibri" pitchFamily="34" charset="0"/>
+                <a:ea typeface="Calibri" pitchFamily="34" charset="-122"/>
+                <a:cs typeface="Calibri" pitchFamily="34" charset="-120"/>
+              </a:rPr>
+              <a:t>SECTION 10  |  VALIDATION &amp; ROADMAP</a:t>
+            </a:r>
+            <a:endParaRPr lang="en-US" sz="850" dirty="0"/>
           </a:p>
         </p:txBody>
       </p:sp>
@@ -3536,7 +3536,7 @@
         </p:nvSpPr>
         <p:spPr>
           <a:xfrm>
-            <a:off x="548640" y="438912"/>
+            <a:off x="548640" y="420624"/>
             <a:ext cx="8046720" cy="347472"/>
           </a:xfrm>
           <a:prstGeom prst="rect">
@@ -3555,7 +3555,7 @@
             <a:r>
               <a:rPr lang="en-US" sz="1800" b="1" dirty="0">
                 <a:solidFill>
-                  <a:srgbClr val="FFFFFF"/>
+                  <a:srgbClr val="0F2942"/>
                 </a:solidFill>
                 <a:latin typeface="Calibri" pitchFamily="34" charset="0"/>
                 <a:ea typeface="Calibri" pitchFamily="34" charset="-122"/>
@@ -3575,7 +3575,7 @@
         </p:nvSpPr>
         <p:spPr>
           <a:xfrm>
-            <a:off x="548640" y="786384"/>
+            <a:off x="548640" y="768096"/>
             <a:ext cx="8046720" cy="201168"/>
           </a:xfrm>
           <a:prstGeom prst="rect">
@@ -3592,9 +3592,9 @@
               <a:buNone/>
             </a:pPr>
             <a:r>
-              <a:rPr lang="en-US" sz="1000" dirty="0">
-                <a:solidFill>
-                  <a:srgbClr val="94A3B8"/>
+              <a:rPr lang="en-US" sz="950" dirty="0">
+                <a:solidFill>
+                  <a:srgbClr val="64748B"/>
                 </a:solidFill>
                 <a:latin typeface="Calibri" pitchFamily="34" charset="0"/>
                 <a:ea typeface="Calibri" pitchFamily="34" charset="-122"/>
@@ -3602,7 +3602,7 @@
               </a:rPr>
               <a:t>Rigorous End-to-End Validation and Upcoming Engineering Enhancements</a:t>
             </a:r>
-            <a:endParaRPr lang="en-US" sz="1000" dirty="0"/>
+            <a:endParaRPr lang="en-US" sz="950" dirty="0"/>
           </a:p>
         </p:txBody>
       </p:sp>
@@ -3614,18 +3614,18 @@
         </p:nvSpPr>
         <p:spPr>
           <a:xfrm>
-            <a:off x="548640" y="1024128"/>
+            <a:off x="548640" y="1005840"/>
             <a:ext cx="8046720" cy="9144"/>
           </a:xfrm>
           <a:prstGeom prst="rect">
             <a:avLst/>
           </a:prstGeom>
           <a:solidFill>
-            <a:srgbClr val="233554"/>
+            <a:srgbClr val="E2E8F0"/>
           </a:solidFill>
           <a:ln w="12700">
             <a:solidFill>
-              <a:srgbClr val="233554"/>
+              <a:srgbClr val="E2E8F0"/>
             </a:solidFill>
             <a:prstDash val="solid"/>
           </a:ln>
@@ -3646,11 +3646,11 @@
             <a:avLst/>
           </a:prstGeom>
           <a:solidFill>
-            <a:srgbClr val="233554"/>
+            <a:srgbClr val="E2E8F0"/>
           </a:solidFill>
           <a:ln w="12700">
             <a:solidFill>
-              <a:srgbClr val="233554"/>
+              <a:srgbClr val="E2E8F0"/>
             </a:solidFill>
             <a:prstDash val="solid"/>
           </a:ln>
@@ -3683,7 +3683,7 @@
             <a:r>
               <a:rPr lang="en-US" sz="850" dirty="0">
                 <a:solidFill>
-                  <a:srgbClr val="94A3B8"/>
+                  <a:srgbClr val="64748B"/>
                 </a:solidFill>
                 <a:latin typeface="Calibri" pitchFamily="34" charset="0"/>
                 <a:ea typeface="Calibri" pitchFamily="34" charset="-122"/>
@@ -3722,7 +3722,7 @@
             <a:r>
               <a:rPr lang="en-US" sz="850" b="1" dirty="0">
                 <a:solidFill>
-                  <a:srgbClr val="38BDF8"/>
+                  <a:srgbClr val="1E40AF"/>
                 </a:solidFill>
                 <a:latin typeface="Calibri" pitchFamily="34" charset="0"/>
                 <a:ea typeface="Calibri" pitchFamily="34" charset="-122"/>
@@ -3749,11 +3749,11 @@
             <a:avLst/>
           </a:prstGeom>
           <a:solidFill>
-            <a:srgbClr val="162238"/>
+            <a:srgbClr val="FFFFFF"/>
           </a:solidFill>
           <a:ln w="12700">
             <a:solidFill>
-              <a:srgbClr val="233554"/>
+              <a:srgbClr val="E2E8F0"/>
             </a:solidFill>
             <a:prstDash val="solid"/>
           </a:ln>
@@ -3774,11 +3774,11 @@
             <a:avLst/>
           </a:prstGeom>
           <a:solidFill>
-            <a:srgbClr val="38BDF8"/>
+            <a:srgbClr val="1E40AF"/>
           </a:solidFill>
           <a:ln w="12700">
             <a:solidFill>
-              <a:srgbClr val="38BDF8"/>
+              <a:srgbClr val="1E40AF"/>
             </a:solidFill>
             <a:prstDash val="solid"/>
           </a:ln>
@@ -3811,7 +3811,7 @@
             <a:r>
               <a:rPr lang="en-US" sz="1100" b="1" dirty="0">
                 <a:solidFill>
-                  <a:srgbClr val="38BDF8"/>
+                  <a:srgbClr val="1E40AF"/>
                 </a:solidFill>
                 <a:latin typeface="Calibri" pitchFamily="34" charset="0"/>
                 <a:ea typeface="Calibri" pitchFamily="34" charset="-122"/>
@@ -3850,7 +3850,7 @@
             <a:r>
               <a:rPr lang="en-US" sz="850" b="1" dirty="0">
                 <a:solidFill>
-                  <a:srgbClr val="38BDF8"/>
+                  <a:srgbClr val="1E40AF"/>
                 </a:solidFill>
                 <a:latin typeface="Calibri" pitchFamily="34" charset="0"/>
                 <a:ea typeface="Calibri" pitchFamily="34" charset="-122"/>
@@ -3865,7 +3865,7 @@
             <a:r>
               <a:rPr lang="en-US" sz="850" dirty="0">
                 <a:solidFill>
-                  <a:srgbClr val="CBD5E1"/>
+                  <a:srgbClr val="334155"/>
                 </a:solidFill>
                 <a:latin typeface="Calibri" pitchFamily="34" charset="0"/>
                 <a:ea typeface="Calibri" pitchFamily="34" charset="-122"/>
@@ -3880,7 +3880,7 @@
             <a:r>
               <a:rPr lang="en-US" sz="850" b="1" dirty="0">
                 <a:solidFill>
-                  <a:srgbClr val="38BDF8"/>
+                  <a:srgbClr val="1E40AF"/>
                 </a:solidFill>
                 <a:latin typeface="Calibri" pitchFamily="34" charset="0"/>
                 <a:ea typeface="Calibri" pitchFamily="34" charset="-122"/>
@@ -3895,7 +3895,7 @@
             <a:r>
               <a:rPr lang="en-US" sz="850" dirty="0">
                 <a:solidFill>
-                  <a:srgbClr val="CBD5E1"/>
+                  <a:srgbClr val="334155"/>
                 </a:solidFill>
                 <a:latin typeface="Calibri" pitchFamily="34" charset="0"/>
                 <a:ea typeface="Calibri" pitchFamily="34" charset="-122"/>
@@ -3910,7 +3910,7 @@
             <a:r>
               <a:rPr lang="en-US" sz="850" b="1" dirty="0">
                 <a:solidFill>
-                  <a:srgbClr val="38BDF8"/>
+                  <a:srgbClr val="1E40AF"/>
                 </a:solidFill>
                 <a:latin typeface="Calibri" pitchFamily="34" charset="0"/>
                 <a:ea typeface="Calibri" pitchFamily="34" charset="-122"/>
@@ -3925,7 +3925,7 @@
             <a:r>
               <a:rPr lang="en-US" sz="850" dirty="0">
                 <a:solidFill>
-                  <a:srgbClr val="CBD5E1"/>
+                  <a:srgbClr val="334155"/>
                 </a:solidFill>
                 <a:latin typeface="Calibri" pitchFamily="34" charset="0"/>
                 <a:ea typeface="Calibri" pitchFamily="34" charset="-122"/>
@@ -3940,7 +3940,7 @@
             <a:r>
               <a:rPr lang="en-US" sz="850" b="1" dirty="0">
                 <a:solidFill>
-                  <a:srgbClr val="38BDF8"/>
+                  <a:srgbClr val="1E40AF"/>
                 </a:solidFill>
                 <a:latin typeface="Calibri" pitchFamily="34" charset="0"/>
                 <a:ea typeface="Calibri" pitchFamily="34" charset="-122"/>
@@ -3955,7 +3955,7 @@
             <a:r>
               <a:rPr lang="en-US" sz="850" dirty="0">
                 <a:solidFill>
-                  <a:srgbClr val="CBD5E1"/>
+                  <a:srgbClr val="334155"/>
                 </a:solidFill>
                 <a:latin typeface="Calibri" pitchFamily="34" charset="0"/>
                 <a:ea typeface="Calibri" pitchFamily="34" charset="-122"/>
@@ -3982,11 +3982,11 @@
             <a:avLst/>
           </a:prstGeom>
           <a:solidFill>
-            <a:srgbClr val="162238"/>
+            <a:srgbClr val="FFFFFF"/>
           </a:solidFill>
           <a:ln w="12700">
             <a:solidFill>
-              <a:srgbClr val="233554"/>
+              <a:srgbClr val="E2E8F0"/>
             </a:solidFill>
             <a:prstDash val="solid"/>
           </a:ln>
@@ -4007,11 +4007,11 @@
             <a:avLst/>
           </a:prstGeom>
           <a:solidFill>
-            <a:srgbClr val="10B981"/>
+            <a:srgbClr val="16A34A"/>
           </a:solidFill>
           <a:ln w="12700">
             <a:solidFill>
-              <a:srgbClr val="10B981"/>
+              <a:srgbClr val="16A34A"/>
             </a:solidFill>
             <a:prstDash val="solid"/>
           </a:ln>
@@ -4044,7 +4044,7 @@
             <a:r>
               <a:rPr lang="en-US" sz="1100" b="1" dirty="0">
                 <a:solidFill>
-                  <a:srgbClr val="34D399"/>
+                  <a:srgbClr val="16A34A"/>
                 </a:solidFill>
                 <a:latin typeface="Calibri" pitchFamily="34" charset="0"/>
                 <a:ea typeface="Calibri" pitchFamily="34" charset="-122"/>
@@ -4083,7 +4083,7 @@
             <a:r>
               <a:rPr lang="en-US" sz="850" b="1" dirty="0">
                 <a:solidFill>
-                  <a:srgbClr val="FFFFFF"/>
+                  <a:srgbClr val="0F172A"/>
                 </a:solidFill>
                 <a:latin typeface="Calibri" pitchFamily="34" charset="0"/>
                 <a:ea typeface="Calibri" pitchFamily="34" charset="-122"/>
@@ -4098,7 +4098,7 @@
             <a:r>
               <a:rPr lang="en-US" sz="850" dirty="0">
                 <a:solidFill>
-                  <a:srgbClr val="CBD5E1"/>
+                  <a:srgbClr val="334155"/>
                 </a:solidFill>
                 <a:latin typeface="Calibri" pitchFamily="34" charset="0"/>
                 <a:ea typeface="Calibri" pitchFamily="34" charset="-122"/>
@@ -4113,7 +4113,7 @@
             <a:r>
               <a:rPr lang="en-US" sz="850" b="1" dirty="0">
                 <a:solidFill>
-                  <a:srgbClr val="FFFFFF"/>
+                  <a:srgbClr val="0F172A"/>
                 </a:solidFill>
                 <a:latin typeface="Calibri" pitchFamily="34" charset="0"/>
                 <a:ea typeface="Calibri" pitchFamily="34" charset="-122"/>
@@ -4128,7 +4128,7 @@
             <a:r>
               <a:rPr lang="en-US" sz="850" dirty="0">
                 <a:solidFill>
-                  <a:srgbClr val="CBD5E1"/>
+                  <a:srgbClr val="334155"/>
                 </a:solidFill>
                 <a:latin typeface="Calibri" pitchFamily="34" charset="0"/>
                 <a:ea typeface="Calibri" pitchFamily="34" charset="-122"/>
@@ -4143,7 +4143,7 @@
             <a:r>
               <a:rPr lang="en-US" sz="850" b="1" dirty="0">
                 <a:solidFill>
-                  <a:srgbClr val="FFFFFF"/>
+                  <a:srgbClr val="0F172A"/>
                 </a:solidFill>
                 <a:latin typeface="Calibri" pitchFamily="34" charset="0"/>
                 <a:ea typeface="Calibri" pitchFamily="34" charset="-122"/>
@@ -4158,7 +4158,7 @@
             <a:r>
               <a:rPr lang="en-US" sz="850" dirty="0">
                 <a:solidFill>
-                  <a:srgbClr val="CBD5E1"/>
+                  <a:srgbClr val="334155"/>
                 </a:solidFill>
                 <a:latin typeface="Calibri" pitchFamily="34" charset="0"/>
                 <a:ea typeface="Calibri" pitchFamily="34" charset="-122"/>
@@ -4173,7 +4173,7 @@
             <a:r>
               <a:rPr lang="en-US" sz="850" b="1" dirty="0">
                 <a:solidFill>
-                  <a:srgbClr val="FFFFFF"/>
+                  <a:srgbClr val="0F172A"/>
                 </a:solidFill>
                 <a:latin typeface="Calibri" pitchFamily="34" charset="0"/>
                 <a:ea typeface="Calibri" pitchFamily="34" charset="-122"/>
@@ -4188,7 +4188,7 @@
             <a:r>
               <a:rPr lang="en-US" sz="850" dirty="0">
                 <a:solidFill>
-                  <a:srgbClr val="CBD5E1"/>
+                  <a:srgbClr val="334155"/>
                 </a:solidFill>
                 <a:latin typeface="Calibri" pitchFamily="34" charset="0"/>
                 <a:ea typeface="Calibri" pitchFamily="34" charset="-122"/>
@@ -4214,7 +4214,7 @@
     <p:bg>
       <p:bgPr>
         <a:solidFill>
-          <a:srgbClr val="0B1329"/>
+          <a:srgbClr val="F8FAFC"/>
         </a:solidFill>
       </p:bgPr>
     </p:bg>
@@ -4247,11 +4247,11 @@
             <a:avLst/>
           </a:prstGeom>
           <a:solidFill>
-            <a:srgbClr val="38BDF8"/>
+            <a:srgbClr val="1E40AF"/>
           </a:solidFill>
           <a:ln w="12700">
             <a:solidFill>
-              <a:srgbClr val="38BDF8"/>
+              <a:srgbClr val="1E40AF"/>
             </a:solidFill>
             <a:prstDash val="solid"/>
           </a:ln>
@@ -4284,7 +4284,7 @@
             <a:r>
               <a:rPr lang="en-US" sz="3200" b="1" dirty="0">
                 <a:solidFill>
-                  <a:srgbClr val="FFFFFF"/>
+                  <a:srgbClr val="0F2942"/>
                 </a:solidFill>
                 <a:latin typeface="Calibri" pitchFamily="34" charset="0"/>
                 <a:ea typeface="Calibri" pitchFamily="34" charset="-122"/>
@@ -4304,7 +4304,7 @@
         </p:nvSpPr>
         <p:spPr>
           <a:xfrm>
-            <a:off x="548640" y="822960"/>
+            <a:off x="548640" y="804672"/>
             <a:ext cx="8046720" cy="256032"/>
           </a:xfrm>
           <a:prstGeom prst="rect">
@@ -4323,7 +4323,7 @@
             <a:r>
               <a:rPr lang="en-US" sz="1300" b="1" dirty="0">
                 <a:solidFill>
-                  <a:srgbClr val="38BDF8"/>
+                  <a:srgbClr val="1E40AF"/>
                 </a:solidFill>
                 <a:latin typeface="Calibri" pitchFamily="34" charset="0"/>
                 <a:ea typeface="Calibri" pitchFamily="34" charset="-122"/>
@@ -4350,11 +4350,11 @@
             <a:avLst/>
           </a:prstGeom>
           <a:solidFill>
-            <a:srgbClr val="162238"/>
+            <a:srgbClr val="FFFFFF"/>
           </a:solidFill>
           <a:ln w="12700">
             <a:solidFill>
-              <a:srgbClr val="233554"/>
+              <a:srgbClr val="E2E8F0"/>
             </a:solidFill>
             <a:prstDash val="solid"/>
           </a:ln>
@@ -4375,11 +4375,11 @@
             <a:avLst/>
           </a:prstGeom>
           <a:solidFill>
-            <a:srgbClr val="10B981"/>
+            <a:srgbClr val="1E40AF"/>
           </a:solidFill>
           <a:ln w="12700">
             <a:solidFill>
-              <a:srgbClr val="10B981"/>
+              <a:srgbClr val="1E40AF"/>
             </a:solidFill>
             <a:prstDash val="solid"/>
           </a:ln>
@@ -4412,7 +4412,7 @@
             <a:r>
               <a:rPr lang="en-US" sz="950" b="1" dirty="0">
                 <a:solidFill>
-                  <a:srgbClr val="34D399"/>
+                  <a:srgbClr val="0F2942"/>
                 </a:solidFill>
                 <a:latin typeface="Calibri" pitchFamily="34" charset="0"/>
                 <a:ea typeface="Calibri" pitchFamily="34" charset="-122"/>
@@ -4451,7 +4451,7 @@
             <a:r>
               <a:rPr lang="en-US" sz="900" dirty="0">
                 <a:solidFill>
-                  <a:srgbClr val="CBD5E1"/>
+                  <a:srgbClr val="334155"/>
                 </a:solidFill>
                 <a:latin typeface="Calibri" pitchFamily="34" charset="0"/>
                 <a:ea typeface="Calibri" pitchFamily="34" charset="-122"/>
@@ -4478,11 +4478,11 @@
             <a:avLst/>
           </a:prstGeom>
           <a:solidFill>
-            <a:srgbClr val="162238"/>
+            <a:srgbClr val="FFFFFF"/>
           </a:solidFill>
           <a:ln w="12700">
             <a:solidFill>
-              <a:srgbClr val="233554"/>
+              <a:srgbClr val="E2E8F0"/>
             </a:solidFill>
             <a:prstDash val="solid"/>
           </a:ln>
@@ -4503,11 +4503,11 @@
             <a:avLst/>
           </a:prstGeom>
           <a:solidFill>
-            <a:srgbClr val="38BDF8"/>
+            <a:srgbClr val="16A34A"/>
           </a:solidFill>
           <a:ln w="12700">
             <a:solidFill>
-              <a:srgbClr val="38BDF8"/>
+              <a:srgbClr val="16A34A"/>
             </a:solidFill>
             <a:prstDash val="solid"/>
           </a:ln>
@@ -4540,7 +4540,7 @@
             <a:r>
               <a:rPr lang="en-US" sz="950" b="1" dirty="0">
                 <a:solidFill>
-                  <a:srgbClr val="38BDF8"/>
+                  <a:srgbClr val="16A34A"/>
                 </a:solidFill>
                 <a:latin typeface="Calibri" pitchFamily="34" charset="0"/>
                 <a:ea typeface="Calibri" pitchFamily="34" charset="-122"/>
@@ -4579,7 +4579,7 @@
             <a:r>
               <a:rPr lang="en-US" sz="850" b="1" dirty="0">
                 <a:solidFill>
-                  <a:srgbClr val="FFFFFF"/>
+                  <a:srgbClr val="0F172A"/>
                 </a:solidFill>
                 <a:latin typeface="Calibri" pitchFamily="34" charset="0"/>
                 <a:ea typeface="Calibri" pitchFamily="34" charset="-122"/>
@@ -4593,7 +4593,7 @@
             <a:r>
               <a:rPr lang="en-US" sz="850" dirty="0">
                 <a:solidFill>
-                  <a:srgbClr val="38BDF8"/>
+                  <a:srgbClr val="1E40AF"/>
                 </a:solidFill>
                 <a:latin typeface="Calibri" pitchFamily="34" charset="0"/>
                 <a:ea typeface="Calibri" pitchFamily="34" charset="-122"/>
@@ -4608,7 +4608,7 @@
             <a:r>
               <a:rPr lang="en-US" sz="850" b="1" dirty="0">
                 <a:solidFill>
-                  <a:srgbClr val="FFFFFF"/>
+                  <a:srgbClr val="0F172A"/>
                 </a:solidFill>
                 <a:latin typeface="Calibri" pitchFamily="34" charset="0"/>
                 <a:ea typeface="Calibri" pitchFamily="34" charset="-122"/>
@@ -4622,7 +4622,7 @@
             <a:r>
               <a:rPr lang="en-US" sz="850" dirty="0">
                 <a:solidFill>
-                  <a:srgbClr val="38BDF8"/>
+                  <a:srgbClr val="1E40AF"/>
                 </a:solidFill>
                 <a:latin typeface="Calibri" pitchFamily="34" charset="0"/>
                 <a:ea typeface="Calibri" pitchFamily="34" charset="-122"/>
@@ -4637,7 +4637,7 @@
             <a:r>
               <a:rPr lang="en-US" sz="850" b="1" dirty="0">
                 <a:solidFill>
-                  <a:srgbClr val="FFFFFF"/>
+                  <a:srgbClr val="0F172A"/>
                 </a:solidFill>
                 <a:latin typeface="Calibri" pitchFamily="34" charset="0"/>
                 <a:ea typeface="Calibri" pitchFamily="34" charset="-122"/>
@@ -4651,7 +4651,7 @@
             <a:r>
               <a:rPr lang="en-US" sz="850" dirty="0">
                 <a:solidFill>
-                  <a:srgbClr val="38BDF8"/>
+                  <a:srgbClr val="1E40AF"/>
                 </a:solidFill>
                 <a:latin typeface="Calibri" pitchFamily="34" charset="0"/>
                 <a:ea typeface="Calibri" pitchFamily="34" charset="-122"/>
@@ -4666,7 +4666,7 @@
             <a:r>
               <a:rPr lang="en-US" sz="850" b="1" dirty="0">
                 <a:solidFill>
-                  <a:srgbClr val="FFFFFF"/>
+                  <a:srgbClr val="0F172A"/>
                 </a:solidFill>
                 <a:latin typeface="Calibri" pitchFamily="34" charset="0"/>
                 <a:ea typeface="Calibri" pitchFamily="34" charset="-122"/>
@@ -4680,7 +4680,7 @@
             <a:r>
               <a:rPr lang="en-US" sz="850" dirty="0">
                 <a:solidFill>
-                  <a:srgbClr val="38BDF8"/>
+                  <a:srgbClr val="1E40AF"/>
                 </a:solidFill>
                 <a:latin typeface="Calibri" pitchFamily="34" charset="0"/>
                 <a:ea typeface="Calibri" pitchFamily="34" charset="-122"/>
@@ -4707,11 +4707,11 @@
             <a:avLst/>
           </a:prstGeom>
           <a:solidFill>
-            <a:srgbClr val="162238"/>
+            <a:srgbClr val="FFFFFF"/>
           </a:solidFill>
           <a:ln w="12700">
             <a:solidFill>
-              <a:srgbClr val="233554"/>
+              <a:srgbClr val="E2E8F0"/>
             </a:solidFill>
             <a:prstDash val="solid"/>
           </a:ln>
@@ -4732,11 +4732,11 @@
             <a:avLst/>
           </a:prstGeom>
           <a:solidFill>
-            <a:srgbClr val="60A5FA"/>
+            <a:srgbClr val="0F2942"/>
           </a:solidFill>
           <a:ln w="12700">
             <a:solidFill>
-              <a:srgbClr val="60A5FA"/>
+              <a:srgbClr val="0F2942"/>
             </a:solidFill>
             <a:prstDash val="solid"/>
           </a:ln>
@@ -4769,7 +4769,7 @@
             <a:r>
               <a:rPr lang="en-US" sz="850" b="1" dirty="0">
                 <a:solidFill>
-                  <a:srgbClr val="94A3B8"/>
+                  <a:srgbClr val="64748B"/>
                 </a:solidFill>
                 <a:latin typeface="Calibri" pitchFamily="34" charset="0"/>
                 <a:ea typeface="Calibri" pitchFamily="34" charset="-122"/>
@@ -4784,7 +4784,7 @@
             <a:r>
               <a:rPr lang="en-US" sz="1400" b="1" dirty="0">
                 <a:solidFill>
-                  <a:srgbClr val="FFFFFF"/>
+                  <a:srgbClr val="0F172A"/>
                 </a:solidFill>
                 <a:latin typeface="Calibri" pitchFamily="34" charset="0"/>
                 <a:ea typeface="Calibri" pitchFamily="34" charset="-122"/>
@@ -4799,7 +4799,7 @@
             <a:r>
               <a:rPr lang="en-US" sz="1100" b="1" dirty="0">
                 <a:solidFill>
-                  <a:srgbClr val="38BDF8"/>
+                  <a:srgbClr val="1E40AF"/>
                 </a:solidFill>
                 <a:latin typeface="Calibri" pitchFamily="34" charset="0"/>
                 <a:ea typeface="Calibri" pitchFamily="34" charset="-122"/>
@@ -4814,7 +4814,7 @@
             <a:r>
               <a:rPr lang="en-US" sz="950" dirty="0">
                 <a:solidFill>
-                  <a:srgbClr val="CBD5E1"/>
+                  <a:srgbClr val="334155"/>
                 </a:solidFill>
                 <a:latin typeface="Calibri" pitchFamily="34" charset="0"/>
                 <a:ea typeface="Calibri" pitchFamily="34" charset="-122"/>
@@ -4829,7 +4829,7 @@
             <a:r>
               <a:rPr lang="en-US" sz="950" b="1" dirty="0">
                 <a:solidFill>
-                  <a:srgbClr val="34D399"/>
+                  <a:srgbClr val="0F2942"/>
                 </a:solidFill>
                 <a:latin typeface="Calibri" pitchFamily="34" charset="0"/>
                 <a:ea typeface="Calibri" pitchFamily="34" charset="-122"/>
@@ -4868,7 +4868,7 @@
             <a:r>
               <a:rPr lang="en-US" sz="850" b="1" dirty="0">
                 <a:solidFill>
-                  <a:srgbClr val="94A3B8"/>
+                  <a:srgbClr val="64748B"/>
                 </a:solidFill>
                 <a:latin typeface="Calibri" pitchFamily="34" charset="0"/>
                 <a:ea typeface="Calibri" pitchFamily="34" charset="-122"/>
@@ -4883,7 +4883,7 @@
             <a:r>
               <a:rPr lang="en-US" sz="1300" b="1" dirty="0">
                 <a:solidFill>
-                  <a:srgbClr val="FFFFFF"/>
+                  <a:srgbClr val="0F172A"/>
                 </a:solidFill>
                 <a:latin typeface="Calibri" pitchFamily="34" charset="0"/>
                 <a:ea typeface="Calibri" pitchFamily="34" charset="-122"/>
@@ -4898,7 +4898,7 @@
             <a:r>
               <a:rPr lang="en-US" sz="1000" dirty="0">
                 <a:solidFill>
-                  <a:srgbClr val="38BDF8"/>
+                  <a:srgbClr val="1E40AF"/>
                 </a:solidFill>
                 <a:latin typeface="Calibri" pitchFamily="34" charset="0"/>
                 <a:ea typeface="Calibri" pitchFamily="34" charset="-122"/>
@@ -4913,7 +4913,7 @@
             <a:r>
               <a:rPr lang="en-US" sz="900" dirty="0">
                 <a:solidFill>
-                  <a:srgbClr val="94A3B8"/>
+                  <a:srgbClr val="64748B"/>
                 </a:solidFill>
                 <a:latin typeface="Calibri" pitchFamily="34" charset="0"/>
                 <a:ea typeface="Calibri" pitchFamily="34" charset="-122"/>
@@ -4952,7 +4952,7 @@
             <a:r>
               <a:rPr lang="en-US" sz="850" dirty="0">
                 <a:solidFill>
-                  <a:srgbClr val="94A3B8"/>
+                  <a:srgbClr val="64748B"/>
                 </a:solidFill>
                 <a:latin typeface="Calibri" pitchFamily="34" charset="0"/>
                 <a:ea typeface="Calibri" pitchFamily="34" charset="-122"/>
@@ -4978,7 +4978,7 @@
     <p:bg>
       <p:bgPr>
         <a:solidFill>
-          <a:srgbClr val="0B1329"/>
+          <a:srgbClr val="F8FAFC"/>
         </a:solidFill>
       </p:bgPr>
     </p:bg>
@@ -5011,11 +5011,11 @@
             <a:avLst/>
           </a:prstGeom>
           <a:solidFill>
-            <a:srgbClr val="38BDF8"/>
+            <a:srgbClr val="1E40AF"/>
           </a:solidFill>
           <a:ln w="12700">
             <a:solidFill>
-              <a:srgbClr val="38BDF8"/>
+              <a:srgbClr val="1E40AF"/>
             </a:solidFill>
             <a:prstDash val="solid"/>
           </a:ln>
@@ -5029,7 +5029,7 @@
         </p:nvSpPr>
         <p:spPr>
           <a:xfrm>
-            <a:off x="548640" y="237744"/>
+            <a:off x="548640" y="219456"/>
             <a:ext cx="5486400" cy="201168"/>
           </a:xfrm>
           <a:prstGeom prst="rect">
@@ -5046,17 +5046,17 @@
               <a:buNone/>
             </a:pPr>
             <a:r>
-              <a:rPr lang="en-US" sz="900" b="1" dirty="0">
-                <a:solidFill>
-                  <a:srgbClr val="38BDF8"/>
-                </a:solidFill>
-                <a:latin typeface="Calibri" pitchFamily="34" charset="0"/>
-                <a:ea typeface="Calibri" pitchFamily="34" charset="-122"/>
-                <a:cs typeface="Calibri" pitchFamily="34" charset="-120"/>
-              </a:rPr>
-              <a:t>GATESYNC  •  01. PROJECT BACKGROUND</a:t>
-            </a:r>
-            <a:endParaRPr lang="en-US" sz="900" dirty="0"/>
+              <a:rPr lang="en-US" sz="850" b="1" dirty="0">
+                <a:solidFill>
+                  <a:srgbClr val="1E40AF"/>
+                </a:solidFill>
+                <a:latin typeface="Calibri" pitchFamily="34" charset="0"/>
+                <a:ea typeface="Calibri" pitchFamily="34" charset="-122"/>
+                <a:cs typeface="Calibri" pitchFamily="34" charset="-120"/>
+              </a:rPr>
+              <a:t>SECTION 01  |  PROJECT BACKGROUND</a:t>
+            </a:r>
+            <a:endParaRPr lang="en-US" sz="850" dirty="0"/>
           </a:p>
         </p:txBody>
       </p:sp>
@@ -5068,7 +5068,7 @@
         </p:nvSpPr>
         <p:spPr>
           <a:xfrm>
-            <a:off x="548640" y="438912"/>
+            <a:off x="548640" y="420624"/>
             <a:ext cx="8046720" cy="347472"/>
           </a:xfrm>
           <a:prstGeom prst="rect">
@@ -5087,7 +5087,7 @@
             <a:r>
               <a:rPr lang="en-US" sz="1800" b="1" dirty="0">
                 <a:solidFill>
-                  <a:srgbClr val="FFFFFF"/>
+                  <a:srgbClr val="0F2942"/>
                 </a:solidFill>
                 <a:latin typeface="Calibri" pitchFamily="34" charset="0"/>
                 <a:ea typeface="Calibri" pitchFamily="34" charset="-122"/>
@@ -5107,7 +5107,7 @@
         </p:nvSpPr>
         <p:spPr>
           <a:xfrm>
-            <a:off x="548640" y="786384"/>
+            <a:off x="548640" y="768096"/>
             <a:ext cx="8046720" cy="201168"/>
           </a:xfrm>
           <a:prstGeom prst="rect">
@@ -5124,17 +5124,17 @@
               <a:buNone/>
             </a:pPr>
             <a:r>
-              <a:rPr lang="en-US" sz="1000" dirty="0">
-                <a:solidFill>
-                  <a:srgbClr val="94A3B8"/>
-                </a:solidFill>
-                <a:latin typeface="Calibri" pitchFamily="34" charset="0"/>
-                <a:ea typeface="Calibri" pitchFamily="34" charset="-122"/>
-                <a:cs typeface="Calibri" pitchFamily="34" charset="-120"/>
-              </a:rPr>
-              <a:t>Operational Vulnerabilities &amp; Friction of Physical Paper Logbooks</a:t>
-            </a:r>
-            <a:endParaRPr lang="en-US" sz="1000" dirty="0"/>
+              <a:rPr lang="en-US" sz="950" dirty="0">
+                <a:solidFill>
+                  <a:srgbClr val="64748B"/>
+                </a:solidFill>
+                <a:latin typeface="Calibri" pitchFamily="34" charset="0"/>
+                <a:ea typeface="Calibri" pitchFamily="34" charset="-122"/>
+                <a:cs typeface="Calibri" pitchFamily="34" charset="-120"/>
+              </a:rPr>
+              <a:t>Operational Vulnerabilities &amp; Bottlenecks of Physical Paper Logbooks</a:t>
+            </a:r>
+            <a:endParaRPr lang="en-US" sz="950" dirty="0"/>
           </a:p>
         </p:txBody>
       </p:sp>
@@ -5146,18 +5146,18 @@
         </p:nvSpPr>
         <p:spPr>
           <a:xfrm>
-            <a:off x="548640" y="1024128"/>
+            <a:off x="548640" y="1005840"/>
             <a:ext cx="8046720" cy="9144"/>
           </a:xfrm>
           <a:prstGeom prst="rect">
             <a:avLst/>
           </a:prstGeom>
           <a:solidFill>
-            <a:srgbClr val="233554"/>
+            <a:srgbClr val="E2E8F0"/>
           </a:solidFill>
           <a:ln w="12700">
             <a:solidFill>
-              <a:srgbClr val="233554"/>
+              <a:srgbClr val="E2E8F0"/>
             </a:solidFill>
             <a:prstDash val="solid"/>
           </a:ln>
@@ -5178,11 +5178,11 @@
             <a:avLst/>
           </a:prstGeom>
           <a:solidFill>
-            <a:srgbClr val="233554"/>
+            <a:srgbClr val="E2E8F0"/>
           </a:solidFill>
           <a:ln w="12700">
             <a:solidFill>
-              <a:srgbClr val="233554"/>
+              <a:srgbClr val="E2E8F0"/>
             </a:solidFill>
             <a:prstDash val="solid"/>
           </a:ln>
@@ -5215,7 +5215,7 @@
             <a:r>
               <a:rPr lang="en-US" sz="850" dirty="0">
                 <a:solidFill>
-                  <a:srgbClr val="94A3B8"/>
+                  <a:srgbClr val="64748B"/>
                 </a:solidFill>
                 <a:latin typeface="Calibri" pitchFamily="34" charset="0"/>
                 <a:ea typeface="Calibri" pitchFamily="34" charset="-122"/>
@@ -5254,7 +5254,7 @@
             <a:r>
               <a:rPr lang="en-US" sz="850" b="1" dirty="0">
                 <a:solidFill>
-                  <a:srgbClr val="38BDF8"/>
+                  <a:srgbClr val="1E40AF"/>
                 </a:solidFill>
                 <a:latin typeface="Calibri" pitchFamily="34" charset="0"/>
                 <a:ea typeface="Calibri" pitchFamily="34" charset="-122"/>
@@ -5281,11 +5281,11 @@
             <a:avLst/>
           </a:prstGeom>
           <a:solidFill>
-            <a:srgbClr val="162238"/>
+            <a:srgbClr val="FFFFFF"/>
           </a:solidFill>
           <a:ln w="12700">
             <a:solidFill>
-              <a:srgbClr val="233554"/>
+              <a:srgbClr val="E2E8F0"/>
             </a:solidFill>
             <a:prstDash val="solid"/>
           </a:ln>
@@ -5306,11 +5306,11 @@
             <a:avLst/>
           </a:prstGeom>
           <a:solidFill>
-            <a:srgbClr val="F87171"/>
+            <a:srgbClr val="DC2626"/>
           </a:solidFill>
           <a:ln w="12700">
             <a:solidFill>
-              <a:srgbClr val="F87171"/>
+              <a:srgbClr val="DC2626"/>
             </a:solidFill>
             <a:prstDash val="solid"/>
           </a:ln>
@@ -5343,7 +5343,7 @@
             <a:r>
               <a:rPr lang="en-US" sz="1100" b="1" dirty="0">
                 <a:solidFill>
-                  <a:srgbClr val="F87171"/>
+                  <a:srgbClr val="DC2626"/>
                 </a:solidFill>
                 <a:latin typeface="Calibri" pitchFamily="34" charset="0"/>
                 <a:ea typeface="Calibri" pitchFamily="34" charset="-122"/>
@@ -5382,7 +5382,7 @@
             <a:r>
               <a:rPr lang="en-US" sz="850" b="1" dirty="0">
                 <a:solidFill>
-                  <a:srgbClr val="FFFFFF"/>
+                  <a:srgbClr val="0F172A"/>
                 </a:solidFill>
                 <a:latin typeface="Calibri" pitchFamily="34" charset="0"/>
                 <a:ea typeface="Calibri" pitchFamily="34" charset="-122"/>
@@ -5397,7 +5397,7 @@
             <a:r>
               <a:rPr lang="en-US" sz="850" dirty="0">
                 <a:solidFill>
-                  <a:srgbClr val="CBD5E1"/>
+                  <a:srgbClr val="334155"/>
                 </a:solidFill>
                 <a:latin typeface="Calibri" pitchFamily="34" charset="0"/>
                 <a:ea typeface="Calibri" pitchFamily="34" charset="-122"/>
@@ -5412,7 +5412,7 @@
             <a:r>
               <a:rPr lang="en-US" sz="850" b="1" dirty="0">
                 <a:solidFill>
-                  <a:srgbClr val="FFFFFF"/>
+                  <a:srgbClr val="0F172A"/>
                 </a:solidFill>
                 <a:latin typeface="Calibri" pitchFamily="34" charset="0"/>
                 <a:ea typeface="Calibri" pitchFamily="34" charset="-122"/>
@@ -5427,7 +5427,7 @@
             <a:r>
               <a:rPr lang="en-US" sz="850" dirty="0">
                 <a:solidFill>
-                  <a:srgbClr val="CBD5E1"/>
+                  <a:srgbClr val="334155"/>
                 </a:solidFill>
                 <a:latin typeface="Calibri" pitchFamily="34" charset="0"/>
                 <a:ea typeface="Calibri" pitchFamily="34" charset="-122"/>
@@ -5442,7 +5442,7 @@
             <a:r>
               <a:rPr lang="en-US" sz="850" b="1" dirty="0">
                 <a:solidFill>
-                  <a:srgbClr val="FFFFFF"/>
+                  <a:srgbClr val="0F172A"/>
                 </a:solidFill>
                 <a:latin typeface="Calibri" pitchFamily="34" charset="0"/>
                 <a:ea typeface="Calibri" pitchFamily="34" charset="-122"/>
@@ -5457,7 +5457,7 @@
             <a:r>
               <a:rPr lang="en-US" sz="850" dirty="0">
                 <a:solidFill>
-                  <a:srgbClr val="CBD5E1"/>
+                  <a:srgbClr val="334155"/>
                 </a:solidFill>
                 <a:latin typeface="Calibri" pitchFamily="34" charset="0"/>
                 <a:ea typeface="Calibri" pitchFamily="34" charset="-122"/>
@@ -5472,7 +5472,7 @@
             <a:r>
               <a:rPr lang="en-US" sz="850" b="1" dirty="0">
                 <a:solidFill>
-                  <a:srgbClr val="FFFFFF"/>
+                  <a:srgbClr val="0F172A"/>
                 </a:solidFill>
                 <a:latin typeface="Calibri" pitchFamily="34" charset="0"/>
                 <a:ea typeface="Calibri" pitchFamily="34" charset="-122"/>
@@ -5487,7 +5487,7 @@
             <a:r>
               <a:rPr lang="en-US" sz="850" dirty="0">
                 <a:solidFill>
-                  <a:srgbClr val="CBD5E1"/>
+                  <a:srgbClr val="334155"/>
                 </a:solidFill>
                 <a:latin typeface="Calibri" pitchFamily="34" charset="0"/>
                 <a:ea typeface="Calibri" pitchFamily="34" charset="-122"/>
@@ -5514,11 +5514,11 @@
             <a:avLst/>
           </a:prstGeom>
           <a:solidFill>
-            <a:srgbClr val="162238"/>
+            <a:srgbClr val="FFFFFF"/>
           </a:solidFill>
           <a:ln w="12700">
             <a:solidFill>
-              <a:srgbClr val="233554"/>
+              <a:srgbClr val="E2E8F0"/>
             </a:solidFill>
             <a:prstDash val="solid"/>
           </a:ln>
@@ -5539,11 +5539,11 @@
             <a:avLst/>
           </a:prstGeom>
           <a:solidFill>
-            <a:srgbClr val="10B981"/>
+            <a:srgbClr val="16A34A"/>
           </a:solidFill>
           <a:ln w="12700">
             <a:solidFill>
-              <a:srgbClr val="10B981"/>
+              <a:srgbClr val="16A34A"/>
             </a:solidFill>
             <a:prstDash val="solid"/>
           </a:ln>
@@ -5576,7 +5576,7 @@
             <a:r>
               <a:rPr lang="en-US" sz="1100" b="1" dirty="0">
                 <a:solidFill>
-                  <a:srgbClr val="34D399"/>
+                  <a:srgbClr val="16A34A"/>
                 </a:solidFill>
                 <a:latin typeface="Calibri" pitchFamily="34" charset="0"/>
                 <a:ea typeface="Calibri" pitchFamily="34" charset="-122"/>
@@ -5615,7 +5615,7 @@
             <a:r>
               <a:rPr lang="en-US" sz="850" b="1" dirty="0">
                 <a:solidFill>
-                  <a:srgbClr val="FFFFFF"/>
+                  <a:srgbClr val="0F172A"/>
                 </a:solidFill>
                 <a:latin typeface="Calibri" pitchFamily="34" charset="0"/>
                 <a:ea typeface="Calibri" pitchFamily="34" charset="-122"/>
@@ -5630,7 +5630,7 @@
             <a:r>
               <a:rPr lang="en-US" sz="850" dirty="0">
                 <a:solidFill>
-                  <a:srgbClr val="CBD5E1"/>
+                  <a:srgbClr val="334155"/>
                 </a:solidFill>
                 <a:latin typeface="Calibri" pitchFamily="34" charset="0"/>
                 <a:ea typeface="Calibri" pitchFamily="34" charset="-122"/>
@@ -5645,7 +5645,7 @@
             <a:r>
               <a:rPr lang="en-US" sz="850" b="1" dirty="0">
                 <a:solidFill>
-                  <a:srgbClr val="FFFFFF"/>
+                  <a:srgbClr val="0F172A"/>
                 </a:solidFill>
                 <a:latin typeface="Calibri" pitchFamily="34" charset="0"/>
                 <a:ea typeface="Calibri" pitchFamily="34" charset="-122"/>
@@ -5660,7 +5660,7 @@
             <a:r>
               <a:rPr lang="en-US" sz="850" dirty="0">
                 <a:solidFill>
-                  <a:srgbClr val="CBD5E1"/>
+                  <a:srgbClr val="334155"/>
                 </a:solidFill>
                 <a:latin typeface="Calibri" pitchFamily="34" charset="0"/>
                 <a:ea typeface="Calibri" pitchFamily="34" charset="-122"/>
@@ -5675,7 +5675,7 @@
             <a:r>
               <a:rPr lang="en-US" sz="850" b="1" dirty="0">
                 <a:solidFill>
-                  <a:srgbClr val="FFFFFF"/>
+                  <a:srgbClr val="0F172A"/>
                 </a:solidFill>
                 <a:latin typeface="Calibri" pitchFamily="34" charset="0"/>
                 <a:ea typeface="Calibri" pitchFamily="34" charset="-122"/>
@@ -5690,7 +5690,7 @@
             <a:r>
               <a:rPr lang="en-US" sz="850" dirty="0">
                 <a:solidFill>
-                  <a:srgbClr val="CBD5E1"/>
+                  <a:srgbClr val="334155"/>
                 </a:solidFill>
                 <a:latin typeface="Calibri" pitchFamily="34" charset="0"/>
                 <a:ea typeface="Calibri" pitchFamily="34" charset="-122"/>
@@ -5705,7 +5705,7 @@
             <a:r>
               <a:rPr lang="en-US" sz="850" b="1" dirty="0">
                 <a:solidFill>
-                  <a:srgbClr val="FFFFFF"/>
+                  <a:srgbClr val="0F172A"/>
                 </a:solidFill>
                 <a:latin typeface="Calibri" pitchFamily="34" charset="0"/>
                 <a:ea typeface="Calibri" pitchFamily="34" charset="-122"/>
@@ -5720,7 +5720,7 @@
             <a:r>
               <a:rPr lang="en-US" sz="850" dirty="0">
                 <a:solidFill>
-                  <a:srgbClr val="CBD5E1"/>
+                  <a:srgbClr val="334155"/>
                 </a:solidFill>
                 <a:latin typeface="Calibri" pitchFamily="34" charset="0"/>
                 <a:ea typeface="Calibri" pitchFamily="34" charset="-122"/>
@@ -5746,7 +5746,7 @@
     <p:bg>
       <p:bgPr>
         <a:solidFill>
-          <a:srgbClr val="0B1329"/>
+          <a:srgbClr val="F8FAFC"/>
         </a:solidFill>
       </p:bgPr>
     </p:bg>
@@ -5779,11 +5779,11 @@
             <a:avLst/>
           </a:prstGeom>
           <a:solidFill>
-            <a:srgbClr val="38BDF8"/>
+            <a:srgbClr val="1E40AF"/>
           </a:solidFill>
           <a:ln w="12700">
             <a:solidFill>
-              <a:srgbClr val="38BDF8"/>
+              <a:srgbClr val="1E40AF"/>
             </a:solidFill>
             <a:prstDash val="solid"/>
           </a:ln>
@@ -5797,7 +5797,7 @@
         </p:nvSpPr>
         <p:spPr>
           <a:xfrm>
-            <a:off x="548640" y="237744"/>
+            <a:off x="548640" y="219456"/>
             <a:ext cx="5486400" cy="201168"/>
           </a:xfrm>
           <a:prstGeom prst="rect">
@@ -5814,17 +5814,17 @@
               <a:buNone/>
             </a:pPr>
             <a:r>
-              <a:rPr lang="en-US" sz="900" b="1" dirty="0">
-                <a:solidFill>
-                  <a:srgbClr val="38BDF8"/>
-                </a:solidFill>
-                <a:latin typeface="Calibri" pitchFamily="34" charset="0"/>
-                <a:ea typeface="Calibri" pitchFamily="34" charset="-122"/>
-                <a:cs typeface="Calibri" pitchFamily="34" charset="-120"/>
-              </a:rPr>
-              <a:t>GATESYNC  •  02. TECHNICAL DESIGN</a:t>
-            </a:r>
-            <a:endParaRPr lang="en-US" sz="900" dirty="0"/>
+              <a:rPr lang="en-US" sz="850" b="1" dirty="0">
+                <a:solidFill>
+                  <a:srgbClr val="1E40AF"/>
+                </a:solidFill>
+                <a:latin typeface="Calibri" pitchFamily="34" charset="0"/>
+                <a:ea typeface="Calibri" pitchFamily="34" charset="-122"/>
+                <a:cs typeface="Calibri" pitchFamily="34" charset="-120"/>
+              </a:rPr>
+              <a:t>SECTION 02  |  TECHNICAL ARCHITECTURE</a:t>
+            </a:r>
+            <a:endParaRPr lang="en-US" sz="850" dirty="0"/>
           </a:p>
         </p:txBody>
       </p:sp>
@@ -5836,7 +5836,7 @@
         </p:nvSpPr>
         <p:spPr>
           <a:xfrm>
-            <a:off x="548640" y="438912"/>
+            <a:off x="548640" y="420624"/>
             <a:ext cx="8046720" cy="347472"/>
           </a:xfrm>
           <a:prstGeom prst="rect">
@@ -5855,7 +5855,7 @@
             <a:r>
               <a:rPr lang="en-US" sz="1800" b="1" dirty="0">
                 <a:solidFill>
-                  <a:srgbClr val="FFFFFF"/>
+                  <a:srgbClr val="0F2942"/>
                 </a:solidFill>
                 <a:latin typeface="Calibri" pitchFamily="34" charset="0"/>
                 <a:ea typeface="Calibri" pitchFamily="34" charset="-122"/>
@@ -5875,7 +5875,7 @@
         </p:nvSpPr>
         <p:spPr>
           <a:xfrm>
-            <a:off x="548640" y="786384"/>
+            <a:off x="548640" y="768096"/>
             <a:ext cx="8046720" cy="201168"/>
           </a:xfrm>
           <a:prstGeom prst="rect">
@@ -5892,9 +5892,9 @@
               <a:buNone/>
             </a:pPr>
             <a:r>
-              <a:rPr lang="en-US" sz="1000" dirty="0">
-                <a:solidFill>
-                  <a:srgbClr val="94A3B8"/>
+              <a:rPr lang="en-US" sz="950" dirty="0">
+                <a:solidFill>
+                  <a:srgbClr val="64748B"/>
                 </a:solidFill>
                 <a:latin typeface="Calibri" pitchFamily="34" charset="0"/>
                 <a:ea typeface="Calibri" pitchFamily="34" charset="-122"/>
@@ -5902,7 +5902,7 @@
               </a:rPr>
               <a:t>Decoupled 3-Tier Enterprise Architecture (Client, Service, Database)</a:t>
             </a:r>
-            <a:endParaRPr lang="en-US" sz="1000" dirty="0"/>
+            <a:endParaRPr lang="en-US" sz="950" dirty="0"/>
           </a:p>
         </p:txBody>
       </p:sp>
@@ -5914,18 +5914,18 @@
         </p:nvSpPr>
         <p:spPr>
           <a:xfrm>
-            <a:off x="548640" y="1024128"/>
+            <a:off x="548640" y="1005840"/>
             <a:ext cx="8046720" cy="9144"/>
           </a:xfrm>
           <a:prstGeom prst="rect">
             <a:avLst/>
           </a:prstGeom>
           <a:solidFill>
-            <a:srgbClr val="233554"/>
+            <a:srgbClr val="E2E8F0"/>
           </a:solidFill>
           <a:ln w="12700">
             <a:solidFill>
-              <a:srgbClr val="233554"/>
+              <a:srgbClr val="E2E8F0"/>
             </a:solidFill>
             <a:prstDash val="solid"/>
           </a:ln>
@@ -5946,11 +5946,11 @@
             <a:avLst/>
           </a:prstGeom>
           <a:solidFill>
-            <a:srgbClr val="233554"/>
+            <a:srgbClr val="E2E8F0"/>
           </a:solidFill>
           <a:ln w="12700">
             <a:solidFill>
-              <a:srgbClr val="233554"/>
+              <a:srgbClr val="E2E8F0"/>
             </a:solidFill>
             <a:prstDash val="solid"/>
           </a:ln>
@@ -5983,7 +5983,7 @@
             <a:r>
               <a:rPr lang="en-US" sz="850" dirty="0">
                 <a:solidFill>
-                  <a:srgbClr val="94A3B8"/>
+                  <a:srgbClr val="64748B"/>
                 </a:solidFill>
                 <a:latin typeface="Calibri" pitchFamily="34" charset="0"/>
                 <a:ea typeface="Calibri" pitchFamily="34" charset="-122"/>
@@ -6022,7 +6022,7 @@
             <a:r>
               <a:rPr lang="en-US" sz="850" b="1" dirty="0">
                 <a:solidFill>
-                  <a:srgbClr val="38BDF8"/>
+                  <a:srgbClr val="1E40AF"/>
                 </a:solidFill>
                 <a:latin typeface="Calibri" pitchFamily="34" charset="0"/>
                 <a:ea typeface="Calibri" pitchFamily="34" charset="-122"/>
@@ -6049,11 +6049,11 @@
             <a:avLst/>
           </a:prstGeom>
           <a:solidFill>
-            <a:srgbClr val="162238"/>
+            <a:srgbClr val="FFFFFF"/>
           </a:solidFill>
           <a:ln w="12700">
             <a:solidFill>
-              <a:srgbClr val="233554"/>
+              <a:srgbClr val="E2E8F0"/>
             </a:solidFill>
             <a:prstDash val="solid"/>
           </a:ln>
@@ -6074,11 +6074,11 @@
             <a:avLst/>
           </a:prstGeom>
           <a:solidFill>
-            <a:srgbClr val="38BDF8"/>
+            <a:srgbClr val="1E40AF"/>
           </a:solidFill>
           <a:ln w="12700">
             <a:solidFill>
-              <a:srgbClr val="38BDF8"/>
+              <a:srgbClr val="1E40AF"/>
             </a:solidFill>
             <a:prstDash val="solid"/>
           </a:ln>
@@ -6111,7 +6111,7 @@
             <a:r>
               <a:rPr lang="en-US" sz="1000" b="1" dirty="0">
                 <a:solidFill>
-                  <a:srgbClr val="38BDF8"/>
+                  <a:srgbClr val="1E40AF"/>
                 </a:solidFill>
                 <a:latin typeface="Calibri" pitchFamily="34" charset="0"/>
                 <a:ea typeface="Calibri" pitchFamily="34" charset="-122"/>
@@ -6150,7 +6150,7 @@
             <a:r>
               <a:rPr lang="en-US" sz="1200" b="1" dirty="0">
                 <a:solidFill>
-                  <a:srgbClr val="FFFFFF"/>
+                  <a:srgbClr val="0F172A"/>
                 </a:solidFill>
                 <a:latin typeface="Calibri" pitchFamily="34" charset="0"/>
                 <a:ea typeface="Calibri" pitchFamily="34" charset="-122"/>
@@ -6189,7 +6189,7 @@
             <a:r>
               <a:rPr lang="en-US" sz="800" b="1" dirty="0">
                 <a:solidFill>
-                  <a:srgbClr val="38BDF8"/>
+                  <a:srgbClr val="0F2942"/>
                 </a:solidFill>
                 <a:latin typeface="Calibri" pitchFamily="34" charset="0"/>
                 <a:ea typeface="Calibri" pitchFamily="34" charset="-122"/>
@@ -6204,7 +6204,7 @@
             <a:r>
               <a:rPr lang="en-US" sz="800" dirty="0">
                 <a:solidFill>
-                  <a:srgbClr val="CBD5E1"/>
+                  <a:srgbClr val="334155"/>
                 </a:solidFill>
                 <a:latin typeface="Calibri" pitchFamily="34" charset="0"/>
                 <a:ea typeface="Calibri" pitchFamily="34" charset="-122"/>
@@ -6219,7 +6219,7 @@
             <a:r>
               <a:rPr lang="en-US" sz="800" b="1" dirty="0">
                 <a:solidFill>
-                  <a:srgbClr val="38BDF8"/>
+                  <a:srgbClr val="0F2942"/>
                 </a:solidFill>
                 <a:latin typeface="Calibri" pitchFamily="34" charset="0"/>
                 <a:ea typeface="Calibri" pitchFamily="34" charset="-122"/>
@@ -6234,7 +6234,7 @@
             <a:r>
               <a:rPr lang="en-US" sz="800" dirty="0">
                 <a:solidFill>
-                  <a:srgbClr val="CBD5E1"/>
+                  <a:srgbClr val="334155"/>
                 </a:solidFill>
                 <a:latin typeface="Calibri" pitchFamily="34" charset="0"/>
                 <a:ea typeface="Calibri" pitchFamily="34" charset="-122"/>
@@ -6249,7 +6249,7 @@
             <a:r>
               <a:rPr lang="en-US" sz="800" b="1" dirty="0">
                 <a:solidFill>
-                  <a:srgbClr val="38BDF8"/>
+                  <a:srgbClr val="0F2942"/>
                 </a:solidFill>
                 <a:latin typeface="Calibri" pitchFamily="34" charset="0"/>
                 <a:ea typeface="Calibri" pitchFamily="34" charset="-122"/>
@@ -6264,13 +6264,13 @@
             <a:r>
               <a:rPr lang="en-US" sz="800" dirty="0">
                 <a:solidFill>
-                  <a:srgbClr val="CBD5E1"/>
-                </a:solidFill>
-                <a:latin typeface="Calibri" pitchFamily="34" charset="0"/>
-                <a:ea typeface="Calibri" pitchFamily="34" charset="-122"/>
-                <a:cs typeface="Calibri" pitchFamily="34" charset="-120"/>
-              </a:rPr>
-              <a:t>Dark-mode executive UI tailored for guard touchscreens, resident phones, and admin portals.
+                  <a:srgbClr val="334155"/>
+                </a:solidFill>
+                <a:latin typeface="Calibri" pitchFamily="34" charset="0"/>
+                <a:ea typeface="Calibri" pitchFamily="34" charset="-122"/>
+                <a:cs typeface="Calibri" pitchFamily="34" charset="-120"/>
+              </a:rPr>
+              <a:t>Modern executive UI tailored for guard touchscreens, resident phones, and admin portals.
 </a:t>
             </a:r>
             <a:pPr indent="0" marL="0">
@@ -6279,7 +6279,7 @@
             <a:r>
               <a:rPr lang="en-US" sz="800" b="1" dirty="0">
                 <a:solidFill>
-                  <a:srgbClr val="38BDF8"/>
+                  <a:srgbClr val="0F2942"/>
                 </a:solidFill>
                 <a:latin typeface="Calibri" pitchFamily="34" charset="0"/>
                 <a:ea typeface="Calibri" pitchFamily="34" charset="-122"/>
@@ -6294,7 +6294,7 @@
             <a:r>
               <a:rPr lang="en-US" sz="800" dirty="0">
                 <a:solidFill>
-                  <a:srgbClr val="CBD5E1"/>
+                  <a:srgbClr val="334155"/>
                 </a:solidFill>
                 <a:latin typeface="Calibri" pitchFamily="34" charset="0"/>
                 <a:ea typeface="Calibri" pitchFamily="34" charset="-122"/>
@@ -6322,11 +6322,11 @@
             <a:avLst/>
           </a:prstGeom>
           <a:solidFill>
-            <a:srgbClr val="162238"/>
+            <a:srgbClr val="FFFFFF"/>
           </a:solidFill>
           <a:ln w="12700">
             <a:solidFill>
-              <a:srgbClr val="233554"/>
+              <a:srgbClr val="E2E8F0"/>
             </a:solidFill>
             <a:prstDash val="solid"/>
           </a:ln>
@@ -6347,11 +6347,11 @@
             <a:avLst/>
           </a:prstGeom>
           <a:solidFill>
-            <a:srgbClr val="60A5FA"/>
+            <a:srgbClr val="0F2942"/>
           </a:solidFill>
           <a:ln w="12700">
             <a:solidFill>
-              <a:srgbClr val="60A5FA"/>
+              <a:srgbClr val="0F2942"/>
             </a:solidFill>
             <a:prstDash val="solid"/>
           </a:ln>
@@ -6384,7 +6384,7 @@
             <a:r>
               <a:rPr lang="en-US" sz="1000" b="1" dirty="0">
                 <a:solidFill>
-                  <a:srgbClr val="60A5FA"/>
+                  <a:srgbClr val="0F2942"/>
                 </a:solidFill>
                 <a:latin typeface="Calibri" pitchFamily="34" charset="0"/>
                 <a:ea typeface="Calibri" pitchFamily="34" charset="-122"/>
@@ -6423,7 +6423,7 @@
             <a:r>
               <a:rPr lang="en-US" sz="1200" b="1" dirty="0">
                 <a:solidFill>
-                  <a:srgbClr val="FFFFFF"/>
+                  <a:srgbClr val="0F172A"/>
                 </a:solidFill>
                 <a:latin typeface="Calibri" pitchFamily="34" charset="0"/>
                 <a:ea typeface="Calibri" pitchFamily="34" charset="-122"/>
@@ -6462,7 +6462,7 @@
             <a:r>
               <a:rPr lang="en-US" sz="800" b="1" dirty="0">
                 <a:solidFill>
-                  <a:srgbClr val="38BDF8"/>
+                  <a:srgbClr val="0F2942"/>
                 </a:solidFill>
                 <a:latin typeface="Calibri" pitchFamily="34" charset="0"/>
                 <a:ea typeface="Calibri" pitchFamily="34" charset="-122"/>
@@ -6477,7 +6477,7 @@
             <a:r>
               <a:rPr lang="en-US" sz="800" dirty="0">
                 <a:solidFill>
-                  <a:srgbClr val="CBD5E1"/>
+                  <a:srgbClr val="334155"/>
                 </a:solidFill>
                 <a:latin typeface="Calibri" pitchFamily="34" charset="0"/>
                 <a:ea typeface="Calibri" pitchFamily="34" charset="-122"/>
@@ -6492,7 +6492,7 @@
             <a:r>
               <a:rPr lang="en-US" sz="800" b="1" dirty="0">
                 <a:solidFill>
-                  <a:srgbClr val="38BDF8"/>
+                  <a:srgbClr val="0F2942"/>
                 </a:solidFill>
                 <a:latin typeface="Calibri" pitchFamily="34" charset="0"/>
                 <a:ea typeface="Calibri" pitchFamily="34" charset="-122"/>
@@ -6507,7 +6507,7 @@
             <a:r>
               <a:rPr lang="en-US" sz="800" dirty="0">
                 <a:solidFill>
-                  <a:srgbClr val="CBD5E1"/>
+                  <a:srgbClr val="334155"/>
                 </a:solidFill>
                 <a:latin typeface="Calibri" pitchFamily="34" charset="0"/>
                 <a:ea typeface="Calibri" pitchFamily="34" charset="-122"/>
@@ -6522,7 +6522,7 @@
             <a:r>
               <a:rPr lang="en-US" sz="800" b="1" dirty="0">
                 <a:solidFill>
-                  <a:srgbClr val="38BDF8"/>
+                  <a:srgbClr val="0F2942"/>
                 </a:solidFill>
                 <a:latin typeface="Calibri" pitchFamily="34" charset="0"/>
                 <a:ea typeface="Calibri" pitchFamily="34" charset="-122"/>
@@ -6537,7 +6537,7 @@
             <a:r>
               <a:rPr lang="en-US" sz="800" dirty="0">
                 <a:solidFill>
-                  <a:srgbClr val="CBD5E1"/>
+                  <a:srgbClr val="334155"/>
                 </a:solidFill>
                 <a:latin typeface="Calibri" pitchFamily="34" charset="0"/>
                 <a:ea typeface="Calibri" pitchFamily="34" charset="-122"/>
@@ -6552,7 +6552,7 @@
             <a:r>
               <a:rPr lang="en-US" sz="800" b="1" dirty="0">
                 <a:solidFill>
-                  <a:srgbClr val="38BDF8"/>
+                  <a:srgbClr val="0F2942"/>
                 </a:solidFill>
                 <a:latin typeface="Calibri" pitchFamily="34" charset="0"/>
                 <a:ea typeface="Calibri" pitchFamily="34" charset="-122"/>
@@ -6567,7 +6567,7 @@
             <a:r>
               <a:rPr lang="en-US" sz="800" dirty="0">
                 <a:solidFill>
-                  <a:srgbClr val="CBD5E1"/>
+                  <a:srgbClr val="334155"/>
                 </a:solidFill>
                 <a:latin typeface="Calibri" pitchFamily="34" charset="0"/>
                 <a:ea typeface="Calibri" pitchFamily="34" charset="-122"/>
@@ -6595,11 +6595,11 @@
             <a:avLst/>
           </a:prstGeom>
           <a:solidFill>
-            <a:srgbClr val="162238"/>
+            <a:srgbClr val="FFFFFF"/>
           </a:solidFill>
           <a:ln w="12700">
             <a:solidFill>
-              <a:srgbClr val="233554"/>
+              <a:srgbClr val="E2E8F0"/>
             </a:solidFill>
             <a:prstDash val="solid"/>
           </a:ln>
@@ -6620,11 +6620,11 @@
             <a:avLst/>
           </a:prstGeom>
           <a:solidFill>
-            <a:srgbClr val="10B981"/>
+            <a:srgbClr val="16A34A"/>
           </a:solidFill>
           <a:ln w="12700">
             <a:solidFill>
-              <a:srgbClr val="10B981"/>
+              <a:srgbClr val="16A34A"/>
             </a:solidFill>
             <a:prstDash val="solid"/>
           </a:ln>
@@ -6657,7 +6657,7 @@
             <a:r>
               <a:rPr lang="en-US" sz="1000" b="1" dirty="0">
                 <a:solidFill>
-                  <a:srgbClr val="10B981"/>
+                  <a:srgbClr val="16A34A"/>
                 </a:solidFill>
                 <a:latin typeface="Calibri" pitchFamily="34" charset="0"/>
                 <a:ea typeface="Calibri" pitchFamily="34" charset="-122"/>
@@ -6696,7 +6696,7 @@
             <a:r>
               <a:rPr lang="en-US" sz="1200" b="1" dirty="0">
                 <a:solidFill>
-                  <a:srgbClr val="FFFFFF"/>
+                  <a:srgbClr val="0F172A"/>
                 </a:solidFill>
                 <a:latin typeface="Calibri" pitchFamily="34" charset="0"/>
                 <a:ea typeface="Calibri" pitchFamily="34" charset="-122"/>
@@ -6735,7 +6735,7 @@
             <a:r>
               <a:rPr lang="en-US" sz="800" b="1" dirty="0">
                 <a:solidFill>
-                  <a:srgbClr val="38BDF8"/>
+                  <a:srgbClr val="0F2942"/>
                 </a:solidFill>
                 <a:latin typeface="Calibri" pitchFamily="34" charset="0"/>
                 <a:ea typeface="Calibri" pitchFamily="34" charset="-122"/>
@@ -6750,7 +6750,7 @@
             <a:r>
               <a:rPr lang="en-US" sz="800" dirty="0">
                 <a:solidFill>
-                  <a:srgbClr val="CBD5E1"/>
+                  <a:srgbClr val="334155"/>
                 </a:solidFill>
                 <a:latin typeface="Calibri" pitchFamily="34" charset="0"/>
                 <a:ea typeface="Calibri" pitchFamily="34" charset="-122"/>
@@ -6765,7 +6765,7 @@
             <a:r>
               <a:rPr lang="en-US" sz="800" b="1" dirty="0">
                 <a:solidFill>
-                  <a:srgbClr val="38BDF8"/>
+                  <a:srgbClr val="0F2942"/>
                 </a:solidFill>
                 <a:latin typeface="Calibri" pitchFamily="34" charset="0"/>
                 <a:ea typeface="Calibri" pitchFamily="34" charset="-122"/>
@@ -6780,7 +6780,7 @@
             <a:r>
               <a:rPr lang="en-US" sz="800" dirty="0">
                 <a:solidFill>
-                  <a:srgbClr val="CBD5E1"/>
+                  <a:srgbClr val="334155"/>
                 </a:solidFill>
                 <a:latin typeface="Calibri" pitchFamily="34" charset="0"/>
                 <a:ea typeface="Calibri" pitchFamily="34" charset="-122"/>
@@ -6795,7 +6795,7 @@
             <a:r>
               <a:rPr lang="en-US" sz="800" b="1" dirty="0">
                 <a:solidFill>
-                  <a:srgbClr val="38BDF8"/>
+                  <a:srgbClr val="0F2942"/>
                 </a:solidFill>
                 <a:latin typeface="Calibri" pitchFamily="34" charset="0"/>
                 <a:ea typeface="Calibri" pitchFamily="34" charset="-122"/>
@@ -6810,7 +6810,7 @@
             <a:r>
               <a:rPr lang="en-US" sz="800" dirty="0">
                 <a:solidFill>
-                  <a:srgbClr val="CBD5E1"/>
+                  <a:srgbClr val="334155"/>
                 </a:solidFill>
                 <a:latin typeface="Calibri" pitchFamily="34" charset="0"/>
                 <a:ea typeface="Calibri" pitchFamily="34" charset="-122"/>
@@ -6825,7 +6825,7 @@
             <a:r>
               <a:rPr lang="en-US" sz="800" b="1" dirty="0">
                 <a:solidFill>
-                  <a:srgbClr val="38BDF8"/>
+                  <a:srgbClr val="0F2942"/>
                 </a:solidFill>
                 <a:latin typeface="Calibri" pitchFamily="34" charset="0"/>
                 <a:ea typeface="Calibri" pitchFamily="34" charset="-122"/>
@@ -6840,7 +6840,7 @@
             <a:r>
               <a:rPr lang="en-US" sz="800" dirty="0">
                 <a:solidFill>
-                  <a:srgbClr val="CBD5E1"/>
+                  <a:srgbClr val="334155"/>
                 </a:solidFill>
                 <a:latin typeface="Calibri" pitchFamily="34" charset="0"/>
                 <a:ea typeface="Calibri" pitchFamily="34" charset="-122"/>
@@ -6867,7 +6867,7 @@
     <p:bg>
       <p:bgPr>
         <a:solidFill>
-          <a:srgbClr val="0B1329"/>
+          <a:srgbClr val="F8FAFC"/>
         </a:solidFill>
       </p:bgPr>
     </p:bg>
@@ -6900,11 +6900,11 @@
             <a:avLst/>
           </a:prstGeom>
           <a:solidFill>
-            <a:srgbClr val="38BDF8"/>
+            <a:srgbClr val="1E40AF"/>
           </a:solidFill>
           <a:ln w="12700">
             <a:solidFill>
-              <a:srgbClr val="38BDF8"/>
+              <a:srgbClr val="1E40AF"/>
             </a:solidFill>
             <a:prstDash val="solid"/>
           </a:ln>
@@ -6918,7 +6918,7 @@
         </p:nvSpPr>
         <p:spPr>
           <a:xfrm>
-            <a:off x="548640" y="237744"/>
+            <a:off x="548640" y="219456"/>
             <a:ext cx="5486400" cy="201168"/>
           </a:xfrm>
           <a:prstGeom prst="rect">
@@ -6935,17 +6935,17 @@
               <a:buNone/>
             </a:pPr>
             <a:r>
-              <a:rPr lang="en-US" sz="900" b="1" dirty="0">
-                <a:solidFill>
-                  <a:srgbClr val="38BDF8"/>
-                </a:solidFill>
-                <a:latin typeface="Calibri" pitchFamily="34" charset="0"/>
-                <a:ea typeface="Calibri" pitchFamily="34" charset="-122"/>
-                <a:cs typeface="Calibri" pitchFamily="34" charset="-120"/>
-              </a:rPr>
-              <a:t>GATESYNC  •  03. OPERATIONAL MODEL</a:t>
-            </a:r>
-            <a:endParaRPr lang="en-US" sz="900" dirty="0"/>
+              <a:rPr lang="en-US" sz="850" b="1" dirty="0">
+                <a:solidFill>
+                  <a:srgbClr val="1E40AF"/>
+                </a:solidFill>
+                <a:latin typeface="Calibri" pitchFamily="34" charset="0"/>
+                <a:ea typeface="Calibri" pitchFamily="34" charset="-122"/>
+                <a:cs typeface="Calibri" pitchFamily="34" charset="-120"/>
+              </a:rPr>
+              <a:t>SECTION 03  |  OPERATIONAL MODEL</a:t>
+            </a:r>
+            <a:endParaRPr lang="en-US" sz="850" dirty="0"/>
           </a:p>
         </p:txBody>
       </p:sp>
@@ -6957,7 +6957,7 @@
         </p:nvSpPr>
         <p:spPr>
           <a:xfrm>
-            <a:off x="548640" y="438912"/>
+            <a:off x="548640" y="420624"/>
             <a:ext cx="8046720" cy="347472"/>
           </a:xfrm>
           <a:prstGeom prst="rect">
@@ -6976,7 +6976,7 @@
             <a:r>
               <a:rPr lang="en-US" sz="1800" b="1" dirty="0">
                 <a:solidFill>
-                  <a:srgbClr val="FFFFFF"/>
+                  <a:srgbClr val="0F2942"/>
                 </a:solidFill>
                 <a:latin typeface="Calibri" pitchFamily="34" charset="0"/>
                 <a:ea typeface="Calibri" pitchFamily="34" charset="-122"/>
@@ -6996,7 +6996,7 @@
         </p:nvSpPr>
         <p:spPr>
           <a:xfrm>
-            <a:off x="548640" y="786384"/>
+            <a:off x="548640" y="768096"/>
             <a:ext cx="8046720" cy="201168"/>
           </a:xfrm>
           <a:prstGeom prst="rect">
@@ -7013,9 +7013,9 @@
               <a:buNone/>
             </a:pPr>
             <a:r>
-              <a:rPr lang="en-US" sz="1000" dirty="0">
-                <a:solidFill>
-                  <a:srgbClr val="94A3B8"/>
+              <a:rPr lang="en-US" sz="950" dirty="0">
+                <a:solidFill>
+                  <a:srgbClr val="64748B"/>
                 </a:solidFill>
                 <a:latin typeface="Calibri" pitchFamily="34" charset="0"/>
                 <a:ea typeface="Calibri" pitchFamily="34" charset="-122"/>
@@ -7023,7 +7023,7 @@
               </a:rPr>
               <a:t>Three Distinct Permission Levels Ensuring Security, Convenience, and Oversight</a:t>
             </a:r>
-            <a:endParaRPr lang="en-US" sz="1000" dirty="0"/>
+            <a:endParaRPr lang="en-US" sz="950" dirty="0"/>
           </a:p>
         </p:txBody>
       </p:sp>
@@ -7035,18 +7035,18 @@
         </p:nvSpPr>
         <p:spPr>
           <a:xfrm>
-            <a:off x="548640" y="1024128"/>
+            <a:off x="548640" y="1005840"/>
             <a:ext cx="8046720" cy="9144"/>
           </a:xfrm>
           <a:prstGeom prst="rect">
             <a:avLst/>
           </a:prstGeom>
           <a:solidFill>
-            <a:srgbClr val="233554"/>
+            <a:srgbClr val="E2E8F0"/>
           </a:solidFill>
           <a:ln w="12700">
             <a:solidFill>
-              <a:srgbClr val="233554"/>
+              <a:srgbClr val="E2E8F0"/>
             </a:solidFill>
             <a:prstDash val="solid"/>
           </a:ln>
@@ -7067,11 +7067,11 @@
             <a:avLst/>
           </a:prstGeom>
           <a:solidFill>
-            <a:srgbClr val="233554"/>
+            <a:srgbClr val="E2E8F0"/>
           </a:solidFill>
           <a:ln w="12700">
             <a:solidFill>
-              <a:srgbClr val="233554"/>
+              <a:srgbClr val="E2E8F0"/>
             </a:solidFill>
             <a:prstDash val="solid"/>
           </a:ln>
@@ -7104,7 +7104,7 @@
             <a:r>
               <a:rPr lang="en-US" sz="850" dirty="0">
                 <a:solidFill>
-                  <a:srgbClr val="94A3B8"/>
+                  <a:srgbClr val="64748B"/>
                 </a:solidFill>
                 <a:latin typeface="Calibri" pitchFamily="34" charset="0"/>
                 <a:ea typeface="Calibri" pitchFamily="34" charset="-122"/>
@@ -7143,7 +7143,7 @@
             <a:r>
               <a:rPr lang="en-US" sz="850" b="1" dirty="0">
                 <a:solidFill>
-                  <a:srgbClr val="38BDF8"/>
+                  <a:srgbClr val="1E40AF"/>
                 </a:solidFill>
                 <a:latin typeface="Calibri" pitchFamily="34" charset="0"/>
                 <a:ea typeface="Calibri" pitchFamily="34" charset="-122"/>
@@ -7170,11 +7170,11 @@
             <a:avLst/>
           </a:prstGeom>
           <a:solidFill>
-            <a:srgbClr val="162238"/>
+            <a:srgbClr val="FFFFFF"/>
           </a:solidFill>
           <a:ln w="12700">
             <a:solidFill>
-              <a:srgbClr val="233554"/>
+              <a:srgbClr val="E2E8F0"/>
             </a:solidFill>
             <a:prstDash val="solid"/>
           </a:ln>
@@ -7195,11 +7195,11 @@
             <a:avLst/>
           </a:prstGeom>
           <a:solidFill>
-            <a:srgbClr val="38BDF8"/>
+            <a:srgbClr val="1E40AF"/>
           </a:solidFill>
           <a:ln w="12700">
             <a:solidFill>
-              <a:srgbClr val="38BDF8"/>
+              <a:srgbClr val="1E40AF"/>
             </a:solidFill>
             <a:prstDash val="solid"/>
           </a:ln>
@@ -7232,7 +7232,7 @@
             <a:r>
               <a:rPr lang="en-US" sz="1000" b="1" dirty="0">
                 <a:solidFill>
-                  <a:srgbClr val="38BDF8"/>
+                  <a:srgbClr val="1E40AF"/>
                 </a:solidFill>
                 <a:latin typeface="Calibri" pitchFamily="34" charset="0"/>
                 <a:ea typeface="Calibri" pitchFamily="34" charset="-122"/>
@@ -7271,7 +7271,7 @@
             <a:r>
               <a:rPr lang="en-US" sz="1200" b="1" dirty="0">
                 <a:solidFill>
-                  <a:srgbClr val="FFFFFF"/>
+                  <a:srgbClr val="0F172A"/>
                 </a:solidFill>
                 <a:latin typeface="Calibri" pitchFamily="34" charset="0"/>
                 <a:ea typeface="Calibri" pitchFamily="34" charset="-122"/>
@@ -7310,7 +7310,7 @@
             <a:r>
               <a:rPr lang="en-US" sz="850" dirty="0">
                 <a:solidFill>
-                  <a:srgbClr val="94A3B8"/>
+                  <a:srgbClr val="64748B"/>
                 </a:solidFill>
                 <a:latin typeface="Calibri" pitchFamily="34" charset="0"/>
                 <a:ea typeface="Calibri" pitchFamily="34" charset="-122"/>
@@ -7349,7 +7349,7 @@
             <a:r>
               <a:rPr lang="en-US" sz="850" b="1" dirty="0">
                 <a:solidFill>
-                  <a:srgbClr val="FFFFFF"/>
+                  <a:srgbClr val="0F172A"/>
                 </a:solidFill>
                 <a:latin typeface="Calibri" pitchFamily="34" charset="0"/>
                 <a:ea typeface="Calibri" pitchFamily="34" charset="-122"/>
@@ -7388,7 +7388,7 @@
             <a:r>
               <a:rPr lang="en-US" sz="850" dirty="0">
                 <a:solidFill>
-                  <a:srgbClr val="CBD5E1"/>
+                  <a:srgbClr val="334155"/>
                 </a:solidFill>
                 <a:latin typeface="Calibri" pitchFamily="34" charset="0"/>
                 <a:ea typeface="Calibri" pitchFamily="34" charset="-122"/>
@@ -7411,7 +7411,7 @@
             <a:r>
               <a:rPr lang="en-US" sz="850" dirty="0">
                 <a:solidFill>
-                  <a:srgbClr val="CBD5E1"/>
+                  <a:srgbClr val="334155"/>
                 </a:solidFill>
                 <a:latin typeface="Calibri" pitchFamily="34" charset="0"/>
                 <a:ea typeface="Calibri" pitchFamily="34" charset="-122"/>
@@ -7434,7 +7434,7 @@
             <a:r>
               <a:rPr lang="en-US" sz="850" dirty="0">
                 <a:solidFill>
-                  <a:srgbClr val="CBD5E1"/>
+                  <a:srgbClr val="334155"/>
                 </a:solidFill>
                 <a:latin typeface="Calibri" pitchFamily="34" charset="0"/>
                 <a:ea typeface="Calibri" pitchFamily="34" charset="-122"/>
@@ -7457,7 +7457,7 @@
             <a:r>
               <a:rPr lang="en-US" sz="850" dirty="0">
                 <a:solidFill>
-                  <a:srgbClr val="CBD5E1"/>
+                  <a:srgbClr val="334155"/>
                 </a:solidFill>
                 <a:latin typeface="Calibri" pitchFamily="34" charset="0"/>
                 <a:ea typeface="Calibri" pitchFamily="34" charset="-122"/>
@@ -7484,11 +7484,11 @@
             <a:avLst/>
           </a:prstGeom>
           <a:solidFill>
-            <a:srgbClr val="162238"/>
+            <a:srgbClr val="FFFFFF"/>
           </a:solidFill>
           <a:ln w="12700">
             <a:solidFill>
-              <a:srgbClr val="233554"/>
+              <a:srgbClr val="E2E8F0"/>
             </a:solidFill>
             <a:prstDash val="solid"/>
           </a:ln>
@@ -7509,11 +7509,11 @@
             <a:avLst/>
           </a:prstGeom>
           <a:solidFill>
-            <a:srgbClr val="60A5FA"/>
+            <a:srgbClr val="0F2942"/>
           </a:solidFill>
           <a:ln w="12700">
             <a:solidFill>
-              <a:srgbClr val="60A5FA"/>
+              <a:srgbClr val="0F2942"/>
             </a:solidFill>
             <a:prstDash val="solid"/>
           </a:ln>
@@ -7546,7 +7546,7 @@
             <a:r>
               <a:rPr lang="en-US" sz="1000" b="1" dirty="0">
                 <a:solidFill>
-                  <a:srgbClr val="60A5FA"/>
+                  <a:srgbClr val="0F2942"/>
                 </a:solidFill>
                 <a:latin typeface="Calibri" pitchFamily="34" charset="0"/>
                 <a:ea typeface="Calibri" pitchFamily="34" charset="-122"/>
@@ -7585,7 +7585,7 @@
             <a:r>
               <a:rPr lang="en-US" sz="1200" b="1" dirty="0">
                 <a:solidFill>
-                  <a:srgbClr val="FFFFFF"/>
+                  <a:srgbClr val="0F172A"/>
                 </a:solidFill>
                 <a:latin typeface="Calibri" pitchFamily="34" charset="0"/>
                 <a:ea typeface="Calibri" pitchFamily="34" charset="-122"/>
@@ -7624,7 +7624,7 @@
             <a:r>
               <a:rPr lang="en-US" sz="850" dirty="0">
                 <a:solidFill>
-                  <a:srgbClr val="94A3B8"/>
+                  <a:srgbClr val="64748B"/>
                 </a:solidFill>
                 <a:latin typeface="Calibri" pitchFamily="34" charset="0"/>
                 <a:ea typeface="Calibri" pitchFamily="34" charset="-122"/>
@@ -7663,7 +7663,7 @@
             <a:r>
               <a:rPr lang="en-US" sz="850" b="1" dirty="0">
                 <a:solidFill>
-                  <a:srgbClr val="FFFFFF"/>
+                  <a:srgbClr val="0F172A"/>
                 </a:solidFill>
                 <a:latin typeface="Calibri" pitchFamily="34" charset="0"/>
                 <a:ea typeface="Calibri" pitchFamily="34" charset="-122"/>
@@ -7702,7 +7702,7 @@
             <a:r>
               <a:rPr lang="en-US" sz="850" dirty="0">
                 <a:solidFill>
-                  <a:srgbClr val="CBD5E1"/>
+                  <a:srgbClr val="334155"/>
                 </a:solidFill>
                 <a:latin typeface="Calibri" pitchFamily="34" charset="0"/>
                 <a:ea typeface="Calibri" pitchFamily="34" charset="-122"/>
@@ -7725,7 +7725,7 @@
             <a:r>
               <a:rPr lang="en-US" sz="850" dirty="0">
                 <a:solidFill>
-                  <a:srgbClr val="CBD5E1"/>
+                  <a:srgbClr val="334155"/>
                 </a:solidFill>
                 <a:latin typeface="Calibri" pitchFamily="34" charset="0"/>
                 <a:ea typeface="Calibri" pitchFamily="34" charset="-122"/>
@@ -7748,7 +7748,7 @@
             <a:r>
               <a:rPr lang="en-US" sz="850" dirty="0">
                 <a:solidFill>
-                  <a:srgbClr val="CBD5E1"/>
+                  <a:srgbClr val="334155"/>
                 </a:solidFill>
                 <a:latin typeface="Calibri" pitchFamily="34" charset="0"/>
                 <a:ea typeface="Calibri" pitchFamily="34" charset="-122"/>
@@ -7771,7 +7771,7 @@
             <a:r>
               <a:rPr lang="en-US" sz="850" dirty="0">
                 <a:solidFill>
-                  <a:srgbClr val="CBD5E1"/>
+                  <a:srgbClr val="334155"/>
                 </a:solidFill>
                 <a:latin typeface="Calibri" pitchFamily="34" charset="0"/>
                 <a:ea typeface="Calibri" pitchFamily="34" charset="-122"/>
@@ -7798,11 +7798,11 @@
             <a:avLst/>
           </a:prstGeom>
           <a:solidFill>
-            <a:srgbClr val="162238"/>
+            <a:srgbClr val="FFFFFF"/>
           </a:solidFill>
           <a:ln w="12700">
             <a:solidFill>
-              <a:srgbClr val="233554"/>
+              <a:srgbClr val="E2E8F0"/>
             </a:solidFill>
             <a:prstDash val="solid"/>
           </a:ln>
@@ -7823,11 +7823,11 @@
             <a:avLst/>
           </a:prstGeom>
           <a:solidFill>
-            <a:srgbClr val="10B981"/>
+            <a:srgbClr val="16A34A"/>
           </a:solidFill>
           <a:ln w="12700">
             <a:solidFill>
-              <a:srgbClr val="10B981"/>
+              <a:srgbClr val="16A34A"/>
             </a:solidFill>
             <a:prstDash val="solid"/>
           </a:ln>
@@ -7860,7 +7860,7 @@
             <a:r>
               <a:rPr lang="en-US" sz="1000" b="1" dirty="0">
                 <a:solidFill>
-                  <a:srgbClr val="10B981"/>
+                  <a:srgbClr val="16A34A"/>
                 </a:solidFill>
                 <a:latin typeface="Calibri" pitchFamily="34" charset="0"/>
                 <a:ea typeface="Calibri" pitchFamily="34" charset="-122"/>
@@ -7899,7 +7899,7 @@
             <a:r>
               <a:rPr lang="en-US" sz="1200" b="1" dirty="0">
                 <a:solidFill>
-                  <a:srgbClr val="FFFFFF"/>
+                  <a:srgbClr val="0F172A"/>
                 </a:solidFill>
                 <a:latin typeface="Calibri" pitchFamily="34" charset="0"/>
                 <a:ea typeface="Calibri" pitchFamily="34" charset="-122"/>
@@ -7938,7 +7938,7 @@
             <a:r>
               <a:rPr lang="en-US" sz="850" dirty="0">
                 <a:solidFill>
-                  <a:srgbClr val="94A3B8"/>
+                  <a:srgbClr val="64748B"/>
                 </a:solidFill>
                 <a:latin typeface="Calibri" pitchFamily="34" charset="0"/>
                 <a:ea typeface="Calibri" pitchFamily="34" charset="-122"/>
@@ -7977,7 +7977,7 @@
             <a:r>
               <a:rPr lang="en-US" sz="850" b="1" dirty="0">
                 <a:solidFill>
-                  <a:srgbClr val="FFFFFF"/>
+                  <a:srgbClr val="0F172A"/>
                 </a:solidFill>
                 <a:latin typeface="Calibri" pitchFamily="34" charset="0"/>
                 <a:ea typeface="Calibri" pitchFamily="34" charset="-122"/>
@@ -8016,7 +8016,7 @@
             <a:r>
               <a:rPr lang="en-US" sz="850" dirty="0">
                 <a:solidFill>
-                  <a:srgbClr val="CBD5E1"/>
+                  <a:srgbClr val="334155"/>
                 </a:solidFill>
                 <a:latin typeface="Calibri" pitchFamily="34" charset="0"/>
                 <a:ea typeface="Calibri" pitchFamily="34" charset="-122"/>
@@ -8039,7 +8039,7 @@
             <a:r>
               <a:rPr lang="en-US" sz="850" dirty="0">
                 <a:solidFill>
-                  <a:srgbClr val="CBD5E1"/>
+                  <a:srgbClr val="334155"/>
                 </a:solidFill>
                 <a:latin typeface="Calibri" pitchFamily="34" charset="0"/>
                 <a:ea typeface="Calibri" pitchFamily="34" charset="-122"/>
@@ -8062,7 +8062,7 @@
             <a:r>
               <a:rPr lang="en-US" sz="850" dirty="0">
                 <a:solidFill>
-                  <a:srgbClr val="CBD5E1"/>
+                  <a:srgbClr val="334155"/>
                 </a:solidFill>
                 <a:latin typeface="Calibri" pitchFamily="34" charset="0"/>
                 <a:ea typeface="Calibri" pitchFamily="34" charset="-122"/>
@@ -8085,7 +8085,7 @@
             <a:r>
               <a:rPr lang="en-US" sz="850" dirty="0">
                 <a:solidFill>
-                  <a:srgbClr val="CBD5E1"/>
+                  <a:srgbClr val="334155"/>
                 </a:solidFill>
                 <a:latin typeface="Calibri" pitchFamily="34" charset="0"/>
                 <a:ea typeface="Calibri" pitchFamily="34" charset="-122"/>
@@ -8111,7 +8111,7 @@
     <p:bg>
       <p:bgPr>
         <a:solidFill>
-          <a:srgbClr val="0B1329"/>
+          <a:srgbClr val="F8FAFC"/>
         </a:solidFill>
       </p:bgPr>
     </p:bg>
@@ -8144,11 +8144,11 @@
             <a:avLst/>
           </a:prstGeom>
           <a:solidFill>
-            <a:srgbClr val="38BDF8"/>
+            <a:srgbClr val="1E40AF"/>
           </a:solidFill>
           <a:ln w="12700">
             <a:solidFill>
-              <a:srgbClr val="38BDF8"/>
+              <a:srgbClr val="1E40AF"/>
             </a:solidFill>
             <a:prstDash val="solid"/>
           </a:ln>
@@ -8162,7 +8162,7 @@
         </p:nvSpPr>
         <p:spPr>
           <a:xfrm>
-            <a:off x="548640" y="237744"/>
+            <a:off x="548640" y="219456"/>
             <a:ext cx="5486400" cy="201168"/>
           </a:xfrm>
           <a:prstGeom prst="rect">
@@ -8179,17 +8179,17 @@
               <a:buNone/>
             </a:pPr>
             <a:r>
-              <a:rPr lang="en-US" sz="900" b="1" dirty="0">
-                <a:solidFill>
-                  <a:srgbClr val="38BDF8"/>
-                </a:solidFill>
-                <a:latin typeface="Calibri" pitchFamily="34" charset="0"/>
-                <a:ea typeface="Calibri" pitchFamily="34" charset="-122"/>
-                <a:cs typeface="Calibri" pitchFamily="34" charset="-120"/>
-              </a:rPr>
-              <a:t>GATESYNC  •  04. MODULE DEEP-DIVE</a:t>
-            </a:r>
-            <a:endParaRPr lang="en-US" sz="900" dirty="0"/>
+              <a:rPr lang="en-US" sz="850" b="1" dirty="0">
+                <a:solidFill>
+                  <a:srgbClr val="1E40AF"/>
+                </a:solidFill>
+                <a:latin typeface="Calibri" pitchFamily="34" charset="0"/>
+                <a:ea typeface="Calibri" pitchFamily="34" charset="-122"/>
+                <a:cs typeface="Calibri" pitchFamily="34" charset="-120"/>
+              </a:rPr>
+              <a:t>SECTION 04  |  MODULE DEEP-DIVE</a:t>
+            </a:r>
+            <a:endParaRPr lang="en-US" sz="850" dirty="0"/>
           </a:p>
         </p:txBody>
       </p:sp>
@@ -8201,7 +8201,7 @@
         </p:nvSpPr>
         <p:spPr>
           <a:xfrm>
-            <a:off x="548640" y="438912"/>
+            <a:off x="548640" y="420624"/>
             <a:ext cx="8046720" cy="347472"/>
           </a:xfrm>
           <a:prstGeom prst="rect">
@@ -8220,7 +8220,7 @@
             <a:r>
               <a:rPr lang="en-US" sz="1800" b="1" dirty="0">
                 <a:solidFill>
-                  <a:srgbClr val="FFFFFF"/>
+                  <a:srgbClr val="0F2942"/>
                 </a:solidFill>
                 <a:latin typeface="Calibri" pitchFamily="34" charset="0"/>
                 <a:ea typeface="Calibri" pitchFamily="34" charset="-122"/>
@@ -8240,7 +8240,7 @@
         </p:nvSpPr>
         <p:spPr>
           <a:xfrm>
-            <a:off x="548640" y="786384"/>
+            <a:off x="548640" y="768096"/>
             <a:ext cx="8046720" cy="201168"/>
           </a:xfrm>
           <a:prstGeom prst="rect">
@@ -8257,9 +8257,9 @@
               <a:buNone/>
             </a:pPr>
             <a:r>
-              <a:rPr lang="en-US" sz="1000" dirty="0">
-                <a:solidFill>
-                  <a:srgbClr val="94A3B8"/>
+              <a:rPr lang="en-US" sz="950" dirty="0">
+                <a:solidFill>
+                  <a:srgbClr val="64748B"/>
                 </a:solidFill>
                 <a:latin typeface="Calibri" pitchFamily="34" charset="0"/>
                 <a:ea typeface="Calibri" pitchFamily="34" charset="-122"/>
@@ -8267,7 +8267,7 @@
               </a:rPr>
               <a:t>High-Speed Visitor Intake Flow Engineered for Zero Gate Congestion</a:t>
             </a:r>
-            <a:endParaRPr lang="en-US" sz="1000" dirty="0"/>
+            <a:endParaRPr lang="en-US" sz="950" dirty="0"/>
           </a:p>
         </p:txBody>
       </p:sp>
@@ -8279,18 +8279,18 @@
         </p:nvSpPr>
         <p:spPr>
           <a:xfrm>
-            <a:off x="548640" y="1024128"/>
+            <a:off x="548640" y="1005840"/>
             <a:ext cx="8046720" cy="9144"/>
           </a:xfrm>
           <a:prstGeom prst="rect">
             <a:avLst/>
           </a:prstGeom>
           <a:solidFill>
-            <a:srgbClr val="233554"/>
+            <a:srgbClr val="E2E8F0"/>
           </a:solidFill>
           <a:ln w="12700">
             <a:solidFill>
-              <a:srgbClr val="233554"/>
+              <a:srgbClr val="E2E8F0"/>
             </a:solidFill>
             <a:prstDash val="solid"/>
           </a:ln>
@@ -8311,11 +8311,11 @@
             <a:avLst/>
           </a:prstGeom>
           <a:solidFill>
-            <a:srgbClr val="233554"/>
+            <a:srgbClr val="E2E8F0"/>
           </a:solidFill>
           <a:ln w="12700">
             <a:solidFill>
-              <a:srgbClr val="233554"/>
+              <a:srgbClr val="E2E8F0"/>
             </a:solidFill>
             <a:prstDash val="solid"/>
           </a:ln>
@@ -8348,7 +8348,7 @@
             <a:r>
               <a:rPr lang="en-US" sz="850" dirty="0">
                 <a:solidFill>
-                  <a:srgbClr val="94A3B8"/>
+                  <a:srgbClr val="64748B"/>
                 </a:solidFill>
                 <a:latin typeface="Calibri" pitchFamily="34" charset="0"/>
                 <a:ea typeface="Calibri" pitchFamily="34" charset="-122"/>
@@ -8387,7 +8387,7 @@
             <a:r>
               <a:rPr lang="en-US" sz="850" b="1" dirty="0">
                 <a:solidFill>
-                  <a:srgbClr val="38BDF8"/>
+                  <a:srgbClr val="1E40AF"/>
                 </a:solidFill>
                 <a:latin typeface="Calibri" pitchFamily="34" charset="0"/>
                 <a:ea typeface="Calibri" pitchFamily="34" charset="-122"/>
@@ -8414,11 +8414,11 @@
             <a:avLst/>
           </a:prstGeom>
           <a:solidFill>
-            <a:srgbClr val="162238"/>
+            <a:srgbClr val="FFFFFF"/>
           </a:solidFill>
           <a:ln w="12700">
             <a:solidFill>
-              <a:srgbClr val="233554"/>
+              <a:srgbClr val="E2E8F0"/>
             </a:solidFill>
             <a:prstDash val="solid"/>
           </a:ln>
@@ -8439,11 +8439,11 @@
             <a:avLst/>
           </a:prstGeom>
           <a:solidFill>
-            <a:srgbClr val="38BDF8"/>
+            <a:srgbClr val="1E40AF"/>
           </a:solidFill>
           <a:ln w="12700">
             <a:solidFill>
-              <a:srgbClr val="38BDF8"/>
+              <a:srgbClr val="1E40AF"/>
             </a:solidFill>
             <a:prstDash val="solid"/>
           </a:ln>
@@ -8476,7 +8476,7 @@
             <a:r>
               <a:rPr lang="en-US" sz="1100" b="1" dirty="0">
                 <a:solidFill>
-                  <a:srgbClr val="38BDF8"/>
+                  <a:srgbClr val="1E40AF"/>
                 </a:solidFill>
                 <a:latin typeface="Calibri" pitchFamily="34" charset="0"/>
                 <a:ea typeface="Calibri" pitchFamily="34" charset="-122"/>
@@ -8515,7 +8515,7 @@
             <a:r>
               <a:rPr lang="en-US" sz="850" b="1" dirty="0">
                 <a:solidFill>
-                  <a:srgbClr val="FFFFFF"/>
+                  <a:srgbClr val="0F172A"/>
                 </a:solidFill>
                 <a:latin typeface="Calibri" pitchFamily="34" charset="0"/>
                 <a:ea typeface="Calibri" pitchFamily="34" charset="-122"/>
@@ -8530,7 +8530,7 @@
             <a:r>
               <a:rPr lang="en-US" sz="850" dirty="0">
                 <a:solidFill>
-                  <a:srgbClr val="CBD5E1"/>
+                  <a:srgbClr val="334155"/>
                 </a:solidFill>
                 <a:latin typeface="Calibri" pitchFamily="34" charset="0"/>
                 <a:ea typeface="Calibri" pitchFamily="34" charset="-122"/>
@@ -8545,7 +8545,7 @@
             <a:r>
               <a:rPr lang="en-US" sz="850" b="1" dirty="0">
                 <a:solidFill>
-                  <a:srgbClr val="FFFFFF"/>
+                  <a:srgbClr val="0F172A"/>
                 </a:solidFill>
                 <a:latin typeface="Calibri" pitchFamily="34" charset="0"/>
                 <a:ea typeface="Calibri" pitchFamily="34" charset="-122"/>
@@ -8560,7 +8560,7 @@
             <a:r>
               <a:rPr lang="en-US" sz="850" dirty="0">
                 <a:solidFill>
-                  <a:srgbClr val="CBD5E1"/>
+                  <a:srgbClr val="334155"/>
                 </a:solidFill>
                 <a:latin typeface="Calibri" pitchFamily="34" charset="0"/>
                 <a:ea typeface="Calibri" pitchFamily="34" charset="-122"/>
@@ -8575,7 +8575,7 @@
             <a:r>
               <a:rPr lang="en-US" sz="850" b="1" dirty="0">
                 <a:solidFill>
-                  <a:srgbClr val="FFFFFF"/>
+                  <a:srgbClr val="0F172A"/>
                 </a:solidFill>
                 <a:latin typeface="Calibri" pitchFamily="34" charset="0"/>
                 <a:ea typeface="Calibri" pitchFamily="34" charset="-122"/>
@@ -8590,7 +8590,7 @@
             <a:r>
               <a:rPr lang="en-US" sz="850" dirty="0">
                 <a:solidFill>
-                  <a:srgbClr val="CBD5E1"/>
+                  <a:srgbClr val="334155"/>
                 </a:solidFill>
                 <a:latin typeface="Calibri" pitchFamily="34" charset="0"/>
                 <a:ea typeface="Calibri" pitchFamily="34" charset="-122"/>
@@ -8605,7 +8605,7 @@
             <a:r>
               <a:rPr lang="en-US" sz="850" b="1" dirty="0">
                 <a:solidFill>
-                  <a:srgbClr val="FFFFFF"/>
+                  <a:srgbClr val="0F172A"/>
                 </a:solidFill>
                 <a:latin typeface="Calibri" pitchFamily="34" charset="0"/>
                 <a:ea typeface="Calibri" pitchFamily="34" charset="-122"/>
@@ -8620,7 +8620,7 @@
             <a:r>
               <a:rPr lang="en-US" sz="850" dirty="0">
                 <a:solidFill>
-                  <a:srgbClr val="CBD5E1"/>
+                  <a:srgbClr val="334155"/>
                 </a:solidFill>
                 <a:latin typeface="Calibri" pitchFamily="34" charset="0"/>
                 <a:ea typeface="Calibri" pitchFamily="34" charset="-122"/>
@@ -8647,11 +8647,11 @@
             <a:avLst/>
           </a:prstGeom>
           <a:solidFill>
-            <a:srgbClr val="162238"/>
+            <a:srgbClr val="FFFFFF"/>
           </a:solidFill>
           <a:ln w="12700">
             <a:solidFill>
-              <a:srgbClr val="233554"/>
+              <a:srgbClr val="E2E8F0"/>
             </a:solidFill>
             <a:prstDash val="solid"/>
           </a:ln>
@@ -8684,7 +8684,7 @@
             <a:r>
               <a:rPr lang="en-US" sz="950" b="1" dirty="0">
                 <a:solidFill>
-                  <a:srgbClr val="38BDF8"/>
+                  <a:srgbClr val="0F2942"/>
                 </a:solidFill>
                 <a:latin typeface="Calibri" pitchFamily="34" charset="0"/>
                 <a:ea typeface="Calibri" pitchFamily="34" charset="-122"/>
@@ -8734,7 +8734,7 @@
     <p:bg>
       <p:bgPr>
         <a:solidFill>
-          <a:srgbClr val="0B1329"/>
+          <a:srgbClr val="F8FAFC"/>
         </a:solidFill>
       </p:bgPr>
     </p:bg>
@@ -8767,11 +8767,11 @@
             <a:avLst/>
           </a:prstGeom>
           <a:solidFill>
-            <a:srgbClr val="38BDF8"/>
+            <a:srgbClr val="1E40AF"/>
           </a:solidFill>
           <a:ln w="12700">
             <a:solidFill>
-              <a:srgbClr val="38BDF8"/>
+              <a:srgbClr val="1E40AF"/>
             </a:solidFill>
             <a:prstDash val="solid"/>
           </a:ln>
@@ -8785,7 +8785,7 @@
         </p:nvSpPr>
         <p:spPr>
           <a:xfrm>
-            <a:off x="548640" y="237744"/>
+            <a:off x="548640" y="219456"/>
             <a:ext cx="5486400" cy="201168"/>
           </a:xfrm>
           <a:prstGeom prst="rect">
@@ -8802,17 +8802,17 @@
               <a:buNone/>
             </a:pPr>
             <a:r>
-              <a:rPr lang="en-US" sz="900" b="1" dirty="0">
-                <a:solidFill>
-                  <a:srgbClr val="38BDF8"/>
-                </a:solidFill>
-                <a:latin typeface="Calibri" pitchFamily="34" charset="0"/>
-                <a:ea typeface="Calibri" pitchFamily="34" charset="-122"/>
-                <a:cs typeface="Calibri" pitchFamily="34" charset="-120"/>
-              </a:rPr>
-              <a:t>GATESYNC  •  05. MODULE DEEP-DIVE</a:t>
-            </a:r>
-            <a:endParaRPr lang="en-US" sz="900" dirty="0"/>
+              <a:rPr lang="en-US" sz="850" b="1" dirty="0">
+                <a:solidFill>
+                  <a:srgbClr val="1E40AF"/>
+                </a:solidFill>
+                <a:latin typeface="Calibri" pitchFamily="34" charset="0"/>
+                <a:ea typeface="Calibri" pitchFamily="34" charset="-122"/>
+                <a:cs typeface="Calibri" pitchFamily="34" charset="-120"/>
+              </a:rPr>
+              <a:t>SECTION 05  |  MODULE DEEP-DIVE</a:t>
+            </a:r>
+            <a:endParaRPr lang="en-US" sz="850" dirty="0"/>
           </a:p>
         </p:txBody>
       </p:sp>
@@ -8824,7 +8824,7 @@
         </p:nvSpPr>
         <p:spPr>
           <a:xfrm>
-            <a:off x="548640" y="438912"/>
+            <a:off x="548640" y="420624"/>
             <a:ext cx="8046720" cy="347472"/>
           </a:xfrm>
           <a:prstGeom prst="rect">
@@ -8843,13 +8843,13 @@
             <a:r>
               <a:rPr lang="en-US" sz="1800" b="1" dirty="0">
                 <a:solidFill>
-                  <a:srgbClr val="FFFFFF"/>
-                </a:solidFill>
-                <a:latin typeface="Calibri" pitchFamily="34" charset="0"/>
-                <a:ea typeface="Calibri" pitchFamily="34" charset="-122"/>
-                <a:cs typeface="Calibri" pitchFamily="34" charset="-120"/>
-              </a:rPr>
-              <a:t>Instant Mobile Push Alert &amp; Remote Approval</a:t>
+                  <a:srgbClr val="0F2942"/>
+                </a:solidFill>
+                <a:latin typeface="Calibri" pitchFamily="34" charset="0"/>
+                <a:ea typeface="Calibri" pitchFamily="34" charset="-122"/>
+                <a:cs typeface="Calibri" pitchFamily="34" charset="-120"/>
+              </a:rPr>
+              <a:t>Resident Instant Push Alert &amp; 1-Tap Approval</a:t>
             </a:r>
             <a:endParaRPr lang="en-US" sz="1800" dirty="0"/>
           </a:p>
@@ -8863,7 +8863,7 @@
         </p:nvSpPr>
         <p:spPr>
           <a:xfrm>
-            <a:off x="548640" y="786384"/>
+            <a:off x="548640" y="768096"/>
             <a:ext cx="8046720" cy="201168"/>
           </a:xfrm>
           <a:prstGeom prst="rect">
@@ -8880,9 +8880,9 @@
               <a:buNone/>
             </a:pPr>
             <a:r>
-              <a:rPr lang="en-US" sz="1000" dirty="0">
-                <a:solidFill>
-                  <a:srgbClr val="94A3B8"/>
+              <a:rPr lang="en-US" sz="950" dirty="0">
+                <a:solidFill>
+                  <a:srgbClr val="64748B"/>
                 </a:solidFill>
                 <a:latin typeface="Calibri" pitchFamily="34" charset="0"/>
                 <a:ea typeface="Calibri" pitchFamily="34" charset="-122"/>
@@ -8890,7 +8890,7 @@
               </a:rPr>
               <a:t>Zero Phone Calls Required — Secure Gate Decisions in Under 2 Seconds</a:t>
             </a:r>
-            <a:endParaRPr lang="en-US" sz="1000" dirty="0"/>
+            <a:endParaRPr lang="en-US" sz="950" dirty="0"/>
           </a:p>
         </p:txBody>
       </p:sp>
@@ -8902,18 +8902,18 @@
         </p:nvSpPr>
         <p:spPr>
           <a:xfrm>
-            <a:off x="548640" y="1024128"/>
+            <a:off x="548640" y="1005840"/>
             <a:ext cx="8046720" cy="9144"/>
           </a:xfrm>
           <a:prstGeom prst="rect">
             <a:avLst/>
           </a:prstGeom>
           <a:solidFill>
-            <a:srgbClr val="233554"/>
+            <a:srgbClr val="E2E8F0"/>
           </a:solidFill>
           <a:ln w="12700">
             <a:solidFill>
-              <a:srgbClr val="233554"/>
+              <a:srgbClr val="E2E8F0"/>
             </a:solidFill>
             <a:prstDash val="solid"/>
           </a:ln>
@@ -8934,11 +8934,11 @@
             <a:avLst/>
           </a:prstGeom>
           <a:solidFill>
-            <a:srgbClr val="233554"/>
+            <a:srgbClr val="E2E8F0"/>
           </a:solidFill>
           <a:ln w="12700">
             <a:solidFill>
-              <a:srgbClr val="233554"/>
+              <a:srgbClr val="E2E8F0"/>
             </a:solidFill>
             <a:prstDash val="solid"/>
           </a:ln>
@@ -8971,7 +8971,7 @@
             <a:r>
               <a:rPr lang="en-US" sz="850" dirty="0">
                 <a:solidFill>
-                  <a:srgbClr val="94A3B8"/>
+                  <a:srgbClr val="64748B"/>
                 </a:solidFill>
                 <a:latin typeface="Calibri" pitchFamily="34" charset="0"/>
                 <a:ea typeface="Calibri" pitchFamily="34" charset="-122"/>
@@ -9010,7 +9010,7 @@
             <a:r>
               <a:rPr lang="en-US" sz="850" b="1" dirty="0">
                 <a:solidFill>
-                  <a:srgbClr val="38BDF8"/>
+                  <a:srgbClr val="1E40AF"/>
                 </a:solidFill>
                 <a:latin typeface="Calibri" pitchFamily="34" charset="0"/>
                 <a:ea typeface="Calibri" pitchFamily="34" charset="-122"/>
@@ -9037,11 +9037,11 @@
             <a:avLst/>
           </a:prstGeom>
           <a:solidFill>
-            <a:srgbClr val="162238"/>
+            <a:srgbClr val="FFFFFF"/>
           </a:solidFill>
           <a:ln w="12700">
             <a:solidFill>
-              <a:srgbClr val="233554"/>
+              <a:srgbClr val="E2E8F0"/>
             </a:solidFill>
             <a:prstDash val="solid"/>
           </a:ln>
@@ -9062,11 +9062,11 @@
             <a:avLst/>
           </a:prstGeom>
           <a:solidFill>
-            <a:srgbClr val="60A5FA"/>
+            <a:srgbClr val="1E40AF"/>
           </a:solidFill>
           <a:ln w="12700">
             <a:solidFill>
-              <a:srgbClr val="60A5FA"/>
+              <a:srgbClr val="1E40AF"/>
             </a:solidFill>
             <a:prstDash val="solid"/>
           </a:ln>
@@ -9099,7 +9099,7 @@
             <a:r>
               <a:rPr lang="en-US" sz="1100" b="1" dirty="0">
                 <a:solidFill>
-                  <a:srgbClr val="60A5FA"/>
+                  <a:srgbClr val="1E40AF"/>
                 </a:solidFill>
                 <a:latin typeface="Calibri" pitchFamily="34" charset="0"/>
                 <a:ea typeface="Calibri" pitchFamily="34" charset="-122"/>
@@ -9138,7 +9138,7 @@
             <a:r>
               <a:rPr lang="en-US" sz="850" b="1" dirty="0">
                 <a:solidFill>
-                  <a:srgbClr val="FFFFFF"/>
+                  <a:srgbClr val="0F172A"/>
                 </a:solidFill>
                 <a:latin typeface="Calibri" pitchFamily="34" charset="0"/>
                 <a:ea typeface="Calibri" pitchFamily="34" charset="-122"/>
@@ -9153,7 +9153,7 @@
             <a:r>
               <a:rPr lang="en-US" sz="850" dirty="0">
                 <a:solidFill>
-                  <a:srgbClr val="CBD5E1"/>
+                  <a:srgbClr val="334155"/>
                 </a:solidFill>
                 <a:latin typeface="Calibri" pitchFamily="34" charset="0"/>
                 <a:ea typeface="Calibri" pitchFamily="34" charset="-122"/>
@@ -9168,7 +9168,7 @@
             <a:r>
               <a:rPr lang="en-US" sz="850" b="1" dirty="0">
                 <a:solidFill>
-                  <a:srgbClr val="FFFFFF"/>
+                  <a:srgbClr val="0F172A"/>
                 </a:solidFill>
                 <a:latin typeface="Calibri" pitchFamily="34" charset="0"/>
                 <a:ea typeface="Calibri" pitchFamily="34" charset="-122"/>
@@ -9183,7 +9183,7 @@
             <a:r>
               <a:rPr lang="en-US" sz="850" dirty="0">
                 <a:solidFill>
-                  <a:srgbClr val="CBD5E1"/>
+                  <a:srgbClr val="334155"/>
                 </a:solidFill>
                 <a:latin typeface="Calibri" pitchFamily="34" charset="0"/>
                 <a:ea typeface="Calibri" pitchFamily="34" charset="-122"/>
@@ -9198,7 +9198,7 @@
             <a:r>
               <a:rPr lang="en-US" sz="850" b="1" dirty="0">
                 <a:solidFill>
-                  <a:srgbClr val="FFFFFF"/>
+                  <a:srgbClr val="0F172A"/>
                 </a:solidFill>
                 <a:latin typeface="Calibri" pitchFamily="34" charset="0"/>
                 <a:ea typeface="Calibri" pitchFamily="34" charset="-122"/>
@@ -9213,7 +9213,7 @@
             <a:r>
               <a:rPr lang="en-US" sz="850" dirty="0">
                 <a:solidFill>
-                  <a:srgbClr val="CBD5E1"/>
+                  <a:srgbClr val="334155"/>
                 </a:solidFill>
                 <a:latin typeface="Calibri" pitchFamily="34" charset="0"/>
                 <a:ea typeface="Calibri" pitchFamily="34" charset="-122"/>
@@ -9228,7 +9228,7 @@
             <a:r>
               <a:rPr lang="en-US" sz="850" b="1" dirty="0">
                 <a:solidFill>
-                  <a:srgbClr val="FFFFFF"/>
+                  <a:srgbClr val="0F172A"/>
                 </a:solidFill>
                 <a:latin typeface="Calibri" pitchFamily="34" charset="0"/>
                 <a:ea typeface="Calibri" pitchFamily="34" charset="-122"/>
@@ -9243,7 +9243,7 @@
             <a:r>
               <a:rPr lang="en-US" sz="850" dirty="0">
                 <a:solidFill>
-                  <a:srgbClr val="CBD5E1"/>
+                  <a:srgbClr val="334155"/>
                 </a:solidFill>
                 <a:latin typeface="Calibri" pitchFamily="34" charset="0"/>
                 <a:ea typeface="Calibri" pitchFamily="34" charset="-122"/>
@@ -9270,11 +9270,11 @@
             <a:avLst/>
           </a:prstGeom>
           <a:solidFill>
-            <a:srgbClr val="162238"/>
+            <a:srgbClr val="FFFFFF"/>
           </a:solidFill>
           <a:ln w="12700">
             <a:solidFill>
-              <a:srgbClr val="233554"/>
+              <a:srgbClr val="E2E8F0"/>
             </a:solidFill>
             <a:prstDash val="solid"/>
           </a:ln>
@@ -9307,7 +9307,7 @@
             <a:r>
               <a:rPr lang="en-US" sz="950" b="1" dirty="0">
                 <a:solidFill>
-                  <a:srgbClr val="60A5FA"/>
+                  <a:srgbClr val="0F2942"/>
                 </a:solidFill>
                 <a:latin typeface="Calibri" pitchFamily="34" charset="0"/>
                 <a:ea typeface="Calibri" pitchFamily="34" charset="-122"/>
@@ -9357,7 +9357,7 @@
     <p:bg>
       <p:bgPr>
         <a:solidFill>
-          <a:srgbClr val="0B1329"/>
+          <a:srgbClr val="F8FAFC"/>
         </a:solidFill>
       </p:bgPr>
     </p:bg>
@@ -9390,11 +9390,11 @@
             <a:avLst/>
           </a:prstGeom>
           <a:solidFill>
-            <a:srgbClr val="38BDF8"/>
+            <a:srgbClr val="1E40AF"/>
           </a:solidFill>
           <a:ln w="12700">
             <a:solidFill>
-              <a:srgbClr val="38BDF8"/>
+              <a:srgbClr val="1E40AF"/>
             </a:solidFill>
             <a:prstDash val="solid"/>
           </a:ln>
@@ -9408,7 +9408,7 @@
         </p:nvSpPr>
         <p:spPr>
           <a:xfrm>
-            <a:off x="548640" y="237744"/>
+            <a:off x="548640" y="219456"/>
             <a:ext cx="5486400" cy="201168"/>
           </a:xfrm>
           <a:prstGeom prst="rect">
@@ -9425,17 +9425,17 @@
               <a:buNone/>
             </a:pPr>
             <a:r>
-              <a:rPr lang="en-US" sz="900" b="1" dirty="0">
-                <a:solidFill>
-                  <a:srgbClr val="38BDF8"/>
-                </a:solidFill>
-                <a:latin typeface="Calibri" pitchFamily="34" charset="0"/>
-                <a:ea typeface="Calibri" pitchFamily="34" charset="-122"/>
-                <a:cs typeface="Calibri" pitchFamily="34" charset="-120"/>
-              </a:rPr>
-              <a:t>GATESYNC  •  06. MODULE DEEP-DIVE</a:t>
-            </a:r>
-            <a:endParaRPr lang="en-US" sz="900" dirty="0"/>
+              <a:rPr lang="en-US" sz="850" b="1" dirty="0">
+                <a:solidFill>
+                  <a:srgbClr val="1E40AF"/>
+                </a:solidFill>
+                <a:latin typeface="Calibri" pitchFamily="34" charset="0"/>
+                <a:ea typeface="Calibri" pitchFamily="34" charset="-122"/>
+                <a:cs typeface="Calibri" pitchFamily="34" charset="-120"/>
+              </a:rPr>
+              <a:t>SECTION 06  |  MODULE DEEP-DIVE</a:t>
+            </a:r>
+            <a:endParaRPr lang="en-US" sz="850" dirty="0"/>
           </a:p>
         </p:txBody>
       </p:sp>
@@ -9447,7 +9447,7 @@
         </p:nvSpPr>
         <p:spPr>
           <a:xfrm>
-            <a:off x="548640" y="438912"/>
+            <a:off x="548640" y="420624"/>
             <a:ext cx="8046720" cy="347472"/>
           </a:xfrm>
           <a:prstGeom prst="rect">
@@ -9466,7 +9466,7 @@
             <a:r>
               <a:rPr lang="en-US" sz="1800" b="1" dirty="0">
                 <a:solidFill>
-                  <a:srgbClr val="FFFFFF"/>
+                  <a:srgbClr val="0F2942"/>
                 </a:solidFill>
                 <a:latin typeface="Calibri" pitchFamily="34" charset="0"/>
                 <a:ea typeface="Calibri" pitchFamily="34" charset="-122"/>
@@ -9486,7 +9486,7 @@
         </p:nvSpPr>
         <p:spPr>
           <a:xfrm>
-            <a:off x="548640" y="786384"/>
+            <a:off x="548640" y="768096"/>
             <a:ext cx="8046720" cy="201168"/>
           </a:xfrm>
           <a:prstGeom prst="rect">
@@ -9503,9 +9503,9 @@
               <a:buNone/>
             </a:pPr>
             <a:r>
-              <a:rPr lang="en-US" sz="1000" dirty="0">
-                <a:solidFill>
-                  <a:srgbClr val="94A3B8"/>
+              <a:rPr lang="en-US" sz="950" dirty="0">
+                <a:solidFill>
+                  <a:srgbClr val="64748B"/>
                 </a:solidFill>
                 <a:latin typeface="Calibri" pitchFamily="34" charset="0"/>
                 <a:ea typeface="Calibri" pitchFamily="34" charset="-122"/>
@@ -9513,7 +9513,7 @@
               </a:rPr>
               <a:t>Frictionless Entry for Family, Party Guests, and Service Personnel</a:t>
             </a:r>
-            <a:endParaRPr lang="en-US" sz="1000" dirty="0"/>
+            <a:endParaRPr lang="en-US" sz="950" dirty="0"/>
           </a:p>
         </p:txBody>
       </p:sp>
@@ -9525,18 +9525,18 @@
         </p:nvSpPr>
         <p:spPr>
           <a:xfrm>
-            <a:off x="548640" y="1024128"/>
+            <a:off x="548640" y="1005840"/>
             <a:ext cx="8046720" cy="9144"/>
           </a:xfrm>
           <a:prstGeom prst="rect">
             <a:avLst/>
           </a:prstGeom>
           <a:solidFill>
-            <a:srgbClr val="233554"/>
+            <a:srgbClr val="E2E8F0"/>
           </a:solidFill>
           <a:ln w="12700">
             <a:solidFill>
-              <a:srgbClr val="233554"/>
+              <a:srgbClr val="E2E8F0"/>
             </a:solidFill>
             <a:prstDash val="solid"/>
           </a:ln>
@@ -9557,11 +9557,11 @@
             <a:avLst/>
           </a:prstGeom>
           <a:solidFill>
-            <a:srgbClr val="233554"/>
+            <a:srgbClr val="E2E8F0"/>
           </a:solidFill>
           <a:ln w="12700">
             <a:solidFill>
-              <a:srgbClr val="233554"/>
+              <a:srgbClr val="E2E8F0"/>
             </a:solidFill>
             <a:prstDash val="solid"/>
           </a:ln>
@@ -9594,7 +9594,7 @@
             <a:r>
               <a:rPr lang="en-US" sz="850" dirty="0">
                 <a:solidFill>
-                  <a:srgbClr val="94A3B8"/>
+                  <a:srgbClr val="64748B"/>
                 </a:solidFill>
                 <a:latin typeface="Calibri" pitchFamily="34" charset="0"/>
                 <a:ea typeface="Calibri" pitchFamily="34" charset="-122"/>
@@ -9633,7 +9633,7 @@
             <a:r>
               <a:rPr lang="en-US" sz="850" b="1" dirty="0">
                 <a:solidFill>
-                  <a:srgbClr val="38BDF8"/>
+                  <a:srgbClr val="1E40AF"/>
                 </a:solidFill>
                 <a:latin typeface="Calibri" pitchFamily="34" charset="0"/>
                 <a:ea typeface="Calibri" pitchFamily="34" charset="-122"/>
@@ -9660,11 +9660,11 @@
             <a:avLst/>
           </a:prstGeom>
           <a:solidFill>
-            <a:srgbClr val="162238"/>
+            <a:srgbClr val="FFFFFF"/>
           </a:solidFill>
           <a:ln w="12700">
             <a:solidFill>
-              <a:srgbClr val="233554"/>
+              <a:srgbClr val="E2E8F0"/>
             </a:solidFill>
             <a:prstDash val="solid"/>
           </a:ln>
@@ -9685,11 +9685,11 @@
             <a:avLst/>
           </a:prstGeom>
           <a:solidFill>
-            <a:srgbClr val="10B981"/>
+            <a:srgbClr val="16A34A"/>
           </a:solidFill>
           <a:ln w="12700">
             <a:solidFill>
-              <a:srgbClr val="10B981"/>
+              <a:srgbClr val="16A34A"/>
             </a:solidFill>
             <a:prstDash val="solid"/>
           </a:ln>
@@ -9722,7 +9722,7 @@
             <a:r>
               <a:rPr lang="en-US" sz="1100" b="1" dirty="0">
                 <a:solidFill>
-                  <a:srgbClr val="34D399"/>
+                  <a:srgbClr val="16A34A"/>
                 </a:solidFill>
                 <a:latin typeface="Calibri" pitchFamily="34" charset="0"/>
                 <a:ea typeface="Calibri" pitchFamily="34" charset="-122"/>
@@ -9761,7 +9761,7 @@
             <a:r>
               <a:rPr lang="en-US" sz="850" b="1" dirty="0">
                 <a:solidFill>
-                  <a:srgbClr val="FFFFFF"/>
+                  <a:srgbClr val="0F172A"/>
                 </a:solidFill>
                 <a:latin typeface="Calibri" pitchFamily="34" charset="0"/>
                 <a:ea typeface="Calibri" pitchFamily="34" charset="-122"/>
@@ -9776,7 +9776,7 @@
             <a:r>
               <a:rPr lang="en-US" sz="850" dirty="0">
                 <a:solidFill>
-                  <a:srgbClr val="CBD5E1"/>
+                  <a:srgbClr val="334155"/>
                 </a:solidFill>
                 <a:latin typeface="Calibri" pitchFamily="34" charset="0"/>
                 <a:ea typeface="Calibri" pitchFamily="34" charset="-122"/>
@@ -9791,7 +9791,7 @@
             <a:r>
               <a:rPr lang="en-US" sz="850" b="1" dirty="0">
                 <a:solidFill>
-                  <a:srgbClr val="FFFFFF"/>
+                  <a:srgbClr val="0F172A"/>
                 </a:solidFill>
                 <a:latin typeface="Calibri" pitchFamily="34" charset="0"/>
                 <a:ea typeface="Calibri" pitchFamily="34" charset="-122"/>
@@ -9806,7 +9806,7 @@
             <a:r>
               <a:rPr lang="en-US" sz="850" dirty="0">
                 <a:solidFill>
-                  <a:srgbClr val="CBD5E1"/>
+                  <a:srgbClr val="334155"/>
                 </a:solidFill>
                 <a:latin typeface="Calibri" pitchFamily="34" charset="0"/>
                 <a:ea typeface="Calibri" pitchFamily="34" charset="-122"/>
@@ -9821,7 +9821,7 @@
             <a:r>
               <a:rPr lang="en-US" sz="850" b="1" dirty="0">
                 <a:solidFill>
-                  <a:srgbClr val="FFFFFF"/>
+                  <a:srgbClr val="0F172A"/>
                 </a:solidFill>
                 <a:latin typeface="Calibri" pitchFamily="34" charset="0"/>
                 <a:ea typeface="Calibri" pitchFamily="34" charset="-122"/>
@@ -9836,7 +9836,7 @@
             <a:r>
               <a:rPr lang="en-US" sz="850" dirty="0">
                 <a:solidFill>
-                  <a:srgbClr val="CBD5E1"/>
+                  <a:srgbClr val="334155"/>
                 </a:solidFill>
                 <a:latin typeface="Calibri" pitchFamily="34" charset="0"/>
                 <a:ea typeface="Calibri" pitchFamily="34" charset="-122"/>
@@ -9851,7 +9851,7 @@
             <a:r>
               <a:rPr lang="en-US" sz="850" b="1" dirty="0">
                 <a:solidFill>
-                  <a:srgbClr val="FFFFFF"/>
+                  <a:srgbClr val="0F172A"/>
                 </a:solidFill>
                 <a:latin typeface="Calibri" pitchFamily="34" charset="0"/>
                 <a:ea typeface="Calibri" pitchFamily="34" charset="-122"/>
@@ -9866,7 +9866,7 @@
             <a:r>
               <a:rPr lang="en-US" sz="850" dirty="0">
                 <a:solidFill>
-                  <a:srgbClr val="CBD5E1"/>
+                  <a:srgbClr val="334155"/>
                 </a:solidFill>
                 <a:latin typeface="Calibri" pitchFamily="34" charset="0"/>
                 <a:ea typeface="Calibri" pitchFamily="34" charset="-122"/>
@@ -9893,11 +9893,11 @@
             <a:avLst/>
           </a:prstGeom>
           <a:solidFill>
-            <a:srgbClr val="162238"/>
+            <a:srgbClr val="FFFFFF"/>
           </a:solidFill>
           <a:ln w="12700">
             <a:solidFill>
-              <a:srgbClr val="233554"/>
+              <a:srgbClr val="E2E8F0"/>
             </a:solidFill>
             <a:prstDash val="solid"/>
           </a:ln>
@@ -9930,7 +9930,7 @@
             <a:r>
               <a:rPr lang="en-US" sz="950" b="1" dirty="0">
                 <a:solidFill>
-                  <a:srgbClr val="34D399"/>
+                  <a:srgbClr val="0F2942"/>
                 </a:solidFill>
                 <a:latin typeface="Calibri" pitchFamily="34" charset="0"/>
                 <a:ea typeface="Calibri" pitchFamily="34" charset="-122"/>
@@ -9980,7 +9980,7 @@
     <p:bg>
       <p:bgPr>
         <a:solidFill>
-          <a:srgbClr val="0B1329"/>
+          <a:srgbClr val="F8FAFC"/>
         </a:solidFill>
       </p:bgPr>
     </p:bg>
@@ -10013,11 +10013,11 @@
             <a:avLst/>
           </a:prstGeom>
           <a:solidFill>
-            <a:srgbClr val="38BDF8"/>
+            <a:srgbClr val="1E40AF"/>
           </a:solidFill>
           <a:ln w="12700">
             <a:solidFill>
-              <a:srgbClr val="38BDF8"/>
+              <a:srgbClr val="1E40AF"/>
             </a:solidFill>
             <a:prstDash val="solid"/>
           </a:ln>
@@ -10031,7 +10031,7 @@
         </p:nvSpPr>
         <p:spPr>
           <a:xfrm>
-            <a:off x="548640" y="237744"/>
+            <a:off x="548640" y="219456"/>
             <a:ext cx="5486400" cy="201168"/>
           </a:xfrm>
           <a:prstGeom prst="rect">
@@ -10048,17 +10048,17 @@
               <a:buNone/>
             </a:pPr>
             <a:r>
-              <a:rPr lang="en-US" sz="900" b="1" dirty="0">
-                <a:solidFill>
-                  <a:srgbClr val="38BDF8"/>
-                </a:solidFill>
-                <a:latin typeface="Calibri" pitchFamily="34" charset="0"/>
-                <a:ea typeface="Calibri" pitchFamily="34" charset="-122"/>
-                <a:cs typeface="Calibri" pitchFamily="34" charset="-120"/>
-              </a:rPr>
-              <a:t>GATESYNC  •  07. MODULE DEEP-DIVE</a:t>
-            </a:r>
-            <a:endParaRPr lang="en-US" sz="900" dirty="0"/>
+              <a:rPr lang="en-US" sz="850" b="1" dirty="0">
+                <a:solidFill>
+                  <a:srgbClr val="1E40AF"/>
+                </a:solidFill>
+                <a:latin typeface="Calibri" pitchFamily="34" charset="0"/>
+                <a:ea typeface="Calibri" pitchFamily="34" charset="-122"/>
+                <a:cs typeface="Calibri" pitchFamily="34" charset="-120"/>
+              </a:rPr>
+              <a:t>SECTION 07  |  MODULE DEEP-DIVE</a:t>
+            </a:r>
+            <a:endParaRPr lang="en-US" sz="850" dirty="0"/>
           </a:p>
         </p:txBody>
       </p:sp>
@@ -10070,7 +10070,7 @@
         </p:nvSpPr>
         <p:spPr>
           <a:xfrm>
-            <a:off x="548640" y="438912"/>
+            <a:off x="548640" y="420624"/>
             <a:ext cx="8046720" cy="347472"/>
           </a:xfrm>
           <a:prstGeom prst="rect">
@@ -10089,7 +10089,7 @@
             <a:r>
               <a:rPr lang="en-US" sz="1800" b="1" dirty="0">
                 <a:solidFill>
-                  <a:srgbClr val="FFFFFF"/>
+                  <a:srgbClr val="0F2942"/>
                 </a:solidFill>
                 <a:latin typeface="Calibri" pitchFamily="34" charset="0"/>
                 <a:ea typeface="Calibri" pitchFamily="34" charset="-122"/>
@@ -10109,7 +10109,7 @@
         </p:nvSpPr>
         <p:spPr>
           <a:xfrm>
-            <a:off x="548640" y="786384"/>
+            <a:off x="548640" y="768096"/>
             <a:ext cx="8046720" cy="201168"/>
           </a:xfrm>
           <a:prstGeom prst="rect">
@@ -10126,9 +10126,9 @@
               <a:buNone/>
             </a:pPr>
             <a:r>
-              <a:rPr lang="en-US" sz="1000" dirty="0">
-                <a:solidFill>
-                  <a:srgbClr val="94A3B8"/>
+              <a:rPr lang="en-US" sz="950" dirty="0">
+                <a:solidFill>
+                  <a:srgbClr val="64748B"/>
                 </a:solidFill>
                 <a:latin typeface="Calibri" pitchFamily="34" charset="0"/>
                 <a:ea typeface="Calibri" pitchFamily="34" charset="-122"/>
@@ -10136,7 +10136,7 @@
               </a:rPr>
               <a:t>Real-Time Visibility Over Society Residents, Staff, and Financial Health</a:t>
             </a:r>
-            <a:endParaRPr lang="en-US" sz="1000" dirty="0"/>
+            <a:endParaRPr lang="en-US" sz="950" dirty="0"/>
           </a:p>
         </p:txBody>
       </p:sp>
@@ -10148,18 +10148,18 @@
         </p:nvSpPr>
         <p:spPr>
           <a:xfrm>
-            <a:off x="548640" y="1024128"/>
+            <a:off x="548640" y="1005840"/>
             <a:ext cx="8046720" cy="9144"/>
           </a:xfrm>
           <a:prstGeom prst="rect">
             <a:avLst/>
           </a:prstGeom>
           <a:solidFill>
-            <a:srgbClr val="233554"/>
+            <a:srgbClr val="E2E8F0"/>
           </a:solidFill>
           <a:ln w="12700">
             <a:solidFill>
-              <a:srgbClr val="233554"/>
+              <a:srgbClr val="E2E8F0"/>
             </a:solidFill>
             <a:prstDash val="solid"/>
           </a:ln>
@@ -10180,11 +10180,11 @@
             <a:avLst/>
           </a:prstGeom>
           <a:solidFill>
-            <a:srgbClr val="233554"/>
+            <a:srgbClr val="E2E8F0"/>
           </a:solidFill>
           <a:ln w="12700">
             <a:solidFill>
-              <a:srgbClr val="233554"/>
+              <a:srgbClr val="E2E8F0"/>
             </a:solidFill>
             <a:prstDash val="solid"/>
           </a:ln>
@@ -10217,7 +10217,7 @@
             <a:r>
               <a:rPr lang="en-US" sz="850" dirty="0">
                 <a:solidFill>
-                  <a:srgbClr val="94A3B8"/>
+                  <a:srgbClr val="64748B"/>
                 </a:solidFill>
                 <a:latin typeface="Calibri" pitchFamily="34" charset="0"/>
                 <a:ea typeface="Calibri" pitchFamily="34" charset="-122"/>
@@ -10256,7 +10256,7 @@
             <a:r>
               <a:rPr lang="en-US" sz="850" b="1" dirty="0">
                 <a:solidFill>
-                  <a:srgbClr val="38BDF8"/>
+                  <a:srgbClr val="1E40AF"/>
                 </a:solidFill>
                 <a:latin typeface="Calibri" pitchFamily="34" charset="0"/>
                 <a:ea typeface="Calibri" pitchFamily="34" charset="-122"/>
@@ -10283,11 +10283,11 @@
             <a:avLst/>
           </a:prstGeom>
           <a:solidFill>
-            <a:srgbClr val="162238"/>
+            <a:srgbClr val="FFFFFF"/>
           </a:solidFill>
           <a:ln w="12700">
             <a:solidFill>
-              <a:srgbClr val="233554"/>
+              <a:srgbClr val="E2E8F0"/>
             </a:solidFill>
             <a:prstDash val="solid"/>
           </a:ln>
@@ -10308,11 +10308,11 @@
             <a:avLst/>
           </a:prstGeom>
           <a:solidFill>
-            <a:srgbClr val="38BDF8"/>
+            <a:srgbClr val="1E40AF"/>
           </a:solidFill>
           <a:ln w="12700">
             <a:solidFill>
-              <a:srgbClr val="38BDF8"/>
+              <a:srgbClr val="1E40AF"/>
             </a:solidFill>
             <a:prstDash val="solid"/>
           </a:ln>
@@ -10345,7 +10345,7 @@
             <a:r>
               <a:rPr lang="en-US" sz="1100" b="1" dirty="0">
                 <a:solidFill>
-                  <a:srgbClr val="38BDF8"/>
+                  <a:srgbClr val="1E40AF"/>
                 </a:solidFill>
                 <a:latin typeface="Calibri" pitchFamily="34" charset="0"/>
                 <a:ea typeface="Calibri" pitchFamily="34" charset="-122"/>
@@ -10384,7 +10384,7 @@
             <a:r>
               <a:rPr lang="en-US" sz="850" b="1" dirty="0">
                 <a:solidFill>
-                  <a:srgbClr val="FFFFFF"/>
+                  <a:srgbClr val="0F172A"/>
                 </a:solidFill>
                 <a:latin typeface="Calibri" pitchFamily="34" charset="0"/>
                 <a:ea typeface="Calibri" pitchFamily="34" charset="-122"/>
@@ -10399,7 +10399,7 @@
             <a:r>
               <a:rPr lang="en-US" sz="850" dirty="0">
                 <a:solidFill>
-                  <a:srgbClr val="CBD5E1"/>
+                  <a:srgbClr val="334155"/>
                 </a:solidFill>
                 <a:latin typeface="Calibri" pitchFamily="34" charset="0"/>
                 <a:ea typeface="Calibri" pitchFamily="34" charset="-122"/>
@@ -10414,7 +10414,7 @@
             <a:r>
               <a:rPr lang="en-US" sz="850" b="1" dirty="0">
                 <a:solidFill>
-                  <a:srgbClr val="FFFFFF"/>
+                  <a:srgbClr val="0F172A"/>
                 </a:solidFill>
                 <a:latin typeface="Calibri" pitchFamily="34" charset="0"/>
                 <a:ea typeface="Calibri" pitchFamily="34" charset="-122"/>
@@ -10429,7 +10429,7 @@
             <a:r>
               <a:rPr lang="en-US" sz="850" dirty="0">
                 <a:solidFill>
-                  <a:srgbClr val="CBD5E1"/>
+                  <a:srgbClr val="334155"/>
                 </a:solidFill>
                 <a:latin typeface="Calibri" pitchFamily="34" charset="0"/>
                 <a:ea typeface="Calibri" pitchFamily="34" charset="-122"/>
@@ -10444,7 +10444,7 @@
             <a:r>
               <a:rPr lang="en-US" sz="850" b="1" dirty="0">
                 <a:solidFill>
-                  <a:srgbClr val="FFFFFF"/>
+                  <a:srgbClr val="0F172A"/>
                 </a:solidFill>
                 <a:latin typeface="Calibri" pitchFamily="34" charset="0"/>
                 <a:ea typeface="Calibri" pitchFamily="34" charset="-122"/>
@@ -10459,7 +10459,7 @@
             <a:r>
               <a:rPr lang="en-US" sz="850" dirty="0">
                 <a:solidFill>
-                  <a:srgbClr val="CBD5E1"/>
+                  <a:srgbClr val="334155"/>
                 </a:solidFill>
                 <a:latin typeface="Calibri" pitchFamily="34" charset="0"/>
                 <a:ea typeface="Calibri" pitchFamily="34" charset="-122"/>
@@ -10474,7 +10474,7 @@
             <a:r>
               <a:rPr lang="en-US" sz="850" b="1" dirty="0">
                 <a:solidFill>
-                  <a:srgbClr val="FFFFFF"/>
+                  <a:srgbClr val="0F172A"/>
                 </a:solidFill>
                 <a:latin typeface="Calibri" pitchFamily="34" charset="0"/>
                 <a:ea typeface="Calibri" pitchFamily="34" charset="-122"/>
@@ -10489,7 +10489,7 @@
             <a:r>
               <a:rPr lang="en-US" sz="850" dirty="0">
                 <a:solidFill>
-                  <a:srgbClr val="CBD5E1"/>
+                  <a:srgbClr val="334155"/>
                 </a:solidFill>
                 <a:latin typeface="Calibri" pitchFamily="34" charset="0"/>
                 <a:ea typeface="Calibri" pitchFamily="34" charset="-122"/>
@@ -10516,11 +10516,11 @@
             <a:avLst/>
           </a:prstGeom>
           <a:solidFill>
-            <a:srgbClr val="162238"/>
+            <a:srgbClr val="FFFFFF"/>
           </a:solidFill>
           <a:ln w="12700">
             <a:solidFill>
-              <a:srgbClr val="233554"/>
+              <a:srgbClr val="E2E8F0"/>
             </a:solidFill>
             <a:prstDash val="solid"/>
           </a:ln>
@@ -10553,7 +10553,7 @@
             <a:r>
               <a:rPr lang="en-US" sz="950" b="1" dirty="0">
                 <a:solidFill>
-                  <a:srgbClr val="38BDF8"/>
+                  <a:srgbClr val="0F2942"/>
                 </a:solidFill>
                 <a:latin typeface="Calibri" pitchFamily="34" charset="0"/>
                 <a:ea typeface="Calibri" pitchFamily="34" charset="-122"/>
@@ -10603,7 +10603,7 @@
     <p:bg>
       <p:bgPr>
         <a:solidFill>
-          <a:srgbClr val="0B1329"/>
+          <a:srgbClr val="F8FAFC"/>
         </a:solidFill>
       </p:bgPr>
     </p:bg>
@@ -10636,11 +10636,11 @@
             <a:avLst/>
           </a:prstGeom>
           <a:solidFill>
-            <a:srgbClr val="38BDF8"/>
+            <a:srgbClr val="1E40AF"/>
           </a:solidFill>
           <a:ln w="12700">
             <a:solidFill>
-              <a:srgbClr val="38BDF8"/>
+              <a:srgbClr val="1E40AF"/>
             </a:solidFill>
             <a:prstDash val="solid"/>
           </a:ln>
@@ -10654,7 +10654,7 @@
         </p:nvSpPr>
         <p:spPr>
           <a:xfrm>
-            <a:off x="548640" y="237744"/>
+            <a:off x="548640" y="219456"/>
             <a:ext cx="5486400" cy="201168"/>
           </a:xfrm>
           <a:prstGeom prst="rect">
@@ -10671,17 +10671,17 @@
               <a:buNone/>
             </a:pPr>
             <a:r>
-              <a:rPr lang="en-US" sz="900" b="1" dirty="0">
-                <a:solidFill>
-                  <a:srgbClr val="38BDF8"/>
-                </a:solidFill>
-                <a:latin typeface="Calibri" pitchFamily="34" charset="0"/>
-                <a:ea typeface="Calibri" pitchFamily="34" charset="-122"/>
-                <a:cs typeface="Calibri" pitchFamily="34" charset="-120"/>
-              </a:rPr>
-              <a:t>GATESYNC  •  08. SECURITY ARCHITECTURE</a:t>
-            </a:r>
-            <a:endParaRPr lang="en-US" sz="900" dirty="0"/>
+              <a:rPr lang="en-US" sz="850" b="1" dirty="0">
+                <a:solidFill>
+                  <a:srgbClr val="1E40AF"/>
+                </a:solidFill>
+                <a:latin typeface="Calibri" pitchFamily="34" charset="0"/>
+                <a:ea typeface="Calibri" pitchFamily="34" charset="-122"/>
+                <a:cs typeface="Calibri" pitchFamily="34" charset="-120"/>
+              </a:rPr>
+              <a:t>SECTION 08  |  SECURITY ARCHITECTURE</a:t>
+            </a:r>
+            <a:endParaRPr lang="en-US" sz="850" dirty="0"/>
           </a:p>
         </p:txBody>
       </p:sp>
@@ -10693,7 +10693,7 @@
         </p:nvSpPr>
         <p:spPr>
           <a:xfrm>
-            <a:off x="548640" y="438912"/>
+            <a:off x="548640" y="420624"/>
             <a:ext cx="8046720" cy="347472"/>
           </a:xfrm>
           <a:prstGeom prst="rect">
@@ -10712,7 +10712,7 @@
             <a:r>
               <a:rPr lang="en-US" sz="1800" b="1" dirty="0">
                 <a:solidFill>
-                  <a:srgbClr val="FFFFFF"/>
+                  <a:srgbClr val="0F2942"/>
                 </a:solidFill>
                 <a:latin typeface="Calibri" pitchFamily="34" charset="0"/>
                 <a:ea typeface="Calibri" pitchFamily="34" charset="-122"/>
@@ -10732,7 +10732,7 @@
         </p:nvSpPr>
         <p:spPr>
           <a:xfrm>
-            <a:off x="548640" y="786384"/>
+            <a:off x="548640" y="768096"/>
             <a:ext cx="8046720" cy="201168"/>
           </a:xfrm>
           <a:prstGeom prst="rect">
@@ -10749,9 +10749,9 @@
               <a:buNone/>
             </a:pPr>
             <a:r>
-              <a:rPr lang="en-US" sz="1000" dirty="0">
-                <a:solidFill>
-                  <a:srgbClr val="94A3B8"/>
+              <a:rPr lang="en-US" sz="950" dirty="0">
+                <a:solidFill>
+                  <a:srgbClr val="64748B"/>
                 </a:solidFill>
                 <a:latin typeface="Calibri" pitchFamily="34" charset="0"/>
                 <a:ea typeface="Calibri" pitchFamily="34" charset="-122"/>
@@ -10759,7 +10759,7 @@
               </a:rPr>
               <a:t>Robust Defense Mechanisms Safeguarding Resident Privacy and Community Assets</a:t>
             </a:r>
-            <a:endParaRPr lang="en-US" sz="1000" dirty="0"/>
+            <a:endParaRPr lang="en-US" sz="950" dirty="0"/>
           </a:p>
         </p:txBody>
       </p:sp>
@@ -10771,18 +10771,18 @@
         </p:nvSpPr>
         <p:spPr>
           <a:xfrm>
-            <a:off x="548640" y="1024128"/>
+            <a:off x="548640" y="1005840"/>
             <a:ext cx="8046720" cy="9144"/>
           </a:xfrm>
           <a:prstGeom prst="rect">
             <a:avLst/>
           </a:prstGeom>
           <a:solidFill>
-            <a:srgbClr val="233554"/>
+            <a:srgbClr val="E2E8F0"/>
           </a:solidFill>
           <a:ln w="12700">
             <a:solidFill>
-              <a:srgbClr val="233554"/>
+              <a:srgbClr val="E2E8F0"/>
             </a:solidFill>
             <a:prstDash val="solid"/>
           </a:ln>
@@ -10803,11 +10803,11 @@
             <a:avLst/>
           </a:prstGeom>
           <a:solidFill>
-            <a:srgbClr val="233554"/>
+            <a:srgbClr val="E2E8F0"/>
           </a:solidFill>
           <a:ln w="12700">
             <a:solidFill>
-              <a:srgbClr val="233554"/>
+              <a:srgbClr val="E2E8F0"/>
             </a:solidFill>
             <a:prstDash val="solid"/>
           </a:ln>
@@ -10840,7 +10840,7 @@
             <a:r>
               <a:rPr lang="en-US" sz="850" dirty="0">
                 <a:solidFill>
-                  <a:srgbClr val="94A3B8"/>
+                  <a:srgbClr val="64748B"/>
                 </a:solidFill>
                 <a:latin typeface="Calibri" pitchFamily="34" charset="0"/>
                 <a:ea typeface="Calibri" pitchFamily="34" charset="-122"/>
@@ -10879,7 +10879,7 @@
             <a:r>
               <a:rPr lang="en-US" sz="850" b="1" dirty="0">
                 <a:solidFill>
-                  <a:srgbClr val="38BDF8"/>
+                  <a:srgbClr val="1E40AF"/>
                 </a:solidFill>
                 <a:latin typeface="Calibri" pitchFamily="34" charset="0"/>
                 <a:ea typeface="Calibri" pitchFamily="34" charset="-122"/>
@@ -10906,11 +10906,11 @@
             <a:avLst/>
           </a:prstGeom>
           <a:solidFill>
-            <a:srgbClr val="162238"/>
+            <a:srgbClr val="FFFFFF"/>
           </a:solidFill>
           <a:ln w="12700">
             <a:solidFill>
-              <a:srgbClr val="233554"/>
+              <a:srgbClr val="E2E8F0"/>
             </a:solidFill>
             <a:prstDash val="solid"/>
           </a:ln>
@@ -10931,11 +10931,11 @@
             <a:avLst/>
           </a:prstGeom>
           <a:solidFill>
-            <a:srgbClr val="38BDF8"/>
+            <a:srgbClr val="1E40AF"/>
           </a:solidFill>
           <a:ln w="12700">
             <a:solidFill>
-              <a:srgbClr val="38BDF8"/>
+              <a:srgbClr val="1E40AF"/>
             </a:solidFill>
             <a:prstDash val="solid"/>
           </a:ln>
@@ -10968,7 +10968,7 @@
             <a:r>
               <a:rPr lang="en-US" sz="1050" b="1" dirty="0">
                 <a:solidFill>
-                  <a:srgbClr val="38BDF8"/>
+                  <a:srgbClr val="1E40AF"/>
                 </a:solidFill>
                 <a:latin typeface="Calibri" pitchFamily="34" charset="0"/>
                 <a:ea typeface="Calibri" pitchFamily="34" charset="-122"/>
@@ -11007,7 +11007,7 @@
             <a:r>
               <a:rPr lang="en-US" sz="900" dirty="0">
                 <a:solidFill>
-                  <a:srgbClr val="CBD5E1"/>
+                  <a:srgbClr val="334155"/>
                 </a:solidFill>
                 <a:latin typeface="Calibri" pitchFamily="34" charset="0"/>
                 <a:ea typeface="Calibri" pitchFamily="34" charset="-122"/>
@@ -11034,11 +11034,11 @@
             <a:avLst/>
           </a:prstGeom>
           <a:solidFill>
-            <a:srgbClr val="162238"/>
+            <a:srgbClr val="FFFFFF"/>
           </a:solidFill>
           <a:ln w="12700">
             <a:solidFill>
-              <a:srgbClr val="233554"/>
+              <a:srgbClr val="E2E8F0"/>
             </a:solidFill>
             <a:prstDash val="solid"/>
           </a:ln>
@@ -11059,11 +11059,11 @@
             <a:avLst/>
           </a:prstGeom>
           <a:solidFill>
-            <a:srgbClr val="60A5FA"/>
+            <a:srgbClr val="0F2942"/>
           </a:solidFill>
           <a:ln w="12700">
             <a:solidFill>
-              <a:srgbClr val="60A5FA"/>
+              <a:srgbClr val="0F2942"/>
             </a:solidFill>
             <a:prstDash val="solid"/>
           </a:ln>
@@ -11096,7 +11096,7 @@
             <a:r>
               <a:rPr lang="en-US" sz="1050" b="1" dirty="0">
                 <a:solidFill>
-                  <a:srgbClr val="60A5FA"/>
+                  <a:srgbClr val="0F2942"/>
                 </a:solidFill>
                 <a:latin typeface="Calibri" pitchFamily="34" charset="0"/>
                 <a:ea typeface="Calibri" pitchFamily="34" charset="-122"/>
@@ -11135,7 +11135,7 @@
             <a:r>
               <a:rPr lang="en-US" sz="900" dirty="0">
                 <a:solidFill>
-                  <a:srgbClr val="CBD5E1"/>
+                  <a:srgbClr val="334155"/>
                 </a:solidFill>
                 <a:latin typeface="Calibri" pitchFamily="34" charset="0"/>
                 <a:ea typeface="Calibri" pitchFamily="34" charset="-122"/>
@@ -11162,11 +11162,11 @@
             <a:avLst/>
           </a:prstGeom>
           <a:solidFill>
-            <a:srgbClr val="162238"/>
+            <a:srgbClr val="FFFFFF"/>
           </a:solidFill>
           <a:ln w="12700">
             <a:solidFill>
-              <a:srgbClr val="233554"/>
+              <a:srgbClr val="E2E8F0"/>
             </a:solidFill>
             <a:prstDash val="solid"/>
           </a:ln>
@@ -11187,11 +11187,11 @@
             <a:avLst/>
           </a:prstGeom>
           <a:solidFill>
-            <a:srgbClr val="10B981"/>
+            <a:srgbClr val="16A34A"/>
           </a:solidFill>
           <a:ln w="12700">
             <a:solidFill>
-              <a:srgbClr val="10B981"/>
+              <a:srgbClr val="16A34A"/>
             </a:solidFill>
             <a:prstDash val="solid"/>
           </a:ln>
@@ -11224,7 +11224,7 @@
             <a:r>
               <a:rPr lang="en-US" sz="1050" b="1" dirty="0">
                 <a:solidFill>
-                  <a:srgbClr val="10B981"/>
+                  <a:srgbClr val="16A34A"/>
                 </a:solidFill>
                 <a:latin typeface="Calibri" pitchFamily="34" charset="0"/>
                 <a:ea typeface="Calibri" pitchFamily="34" charset="-122"/>
@@ -11263,7 +11263,7 @@
             <a:r>
               <a:rPr lang="en-US" sz="900" dirty="0">
                 <a:solidFill>
-                  <a:srgbClr val="CBD5E1"/>
+                  <a:srgbClr val="334155"/>
                 </a:solidFill>
                 <a:latin typeface="Calibri" pitchFamily="34" charset="0"/>
                 <a:ea typeface="Calibri" pitchFamily="34" charset="-122"/>
@@ -11290,11 +11290,11 @@
             <a:avLst/>
           </a:prstGeom>
           <a:solidFill>
-            <a:srgbClr val="162238"/>
+            <a:srgbClr val="FFFFFF"/>
           </a:solidFill>
           <a:ln w="12700">
             <a:solidFill>
-              <a:srgbClr val="233554"/>
+              <a:srgbClr val="E2E8F0"/>
             </a:solidFill>
             <a:prstDash val="solid"/>
           </a:ln>
@@ -11315,11 +11315,11 @@
             <a:avLst/>
           </a:prstGeom>
           <a:solidFill>
-            <a:srgbClr val="34D399"/>
+            <a:srgbClr val="0284C7"/>
           </a:solidFill>
           <a:ln w="12700">
             <a:solidFill>
-              <a:srgbClr val="34D399"/>
+              <a:srgbClr val="0284C7"/>
             </a:solidFill>
             <a:prstDash val="solid"/>
           </a:ln>
@@ -11352,7 +11352,7 @@
             <a:r>
               <a:rPr lang="en-US" sz="1050" b="1" dirty="0">
                 <a:solidFill>
-                  <a:srgbClr val="34D399"/>
+                  <a:srgbClr val="0284C7"/>
                 </a:solidFill>
                 <a:latin typeface="Calibri" pitchFamily="34" charset="0"/>
                 <a:ea typeface="Calibri" pitchFamily="34" charset="-122"/>
@@ -11391,7 +11391,7 @@
             <a:r>
               <a:rPr lang="en-US" sz="900" dirty="0">
                 <a:solidFill>
-                  <a:srgbClr val="CBD5E1"/>
+                  <a:srgbClr val="334155"/>
                 </a:solidFill>
                 <a:latin typeface="Calibri" pitchFamily="34" charset="0"/>
                 <a:ea typeface="Calibri" pitchFamily="34" charset="-122"/>

</xml_diff>

<commit_message>
Update presentation: integrate white theme dashboard image and clean live links
</commit_message>
<xml_diff>
--- a/GateSync_Project_Presentation.pptx
+++ b/GateSync_Project_Presentation.pptx
@@ -4094,7 +4094,7 @@
               <a:buNone/>
             </a:pPr>
             <a:r>
-              <a:rPr lang="en-US" sz="900" b="1" dirty="0">
+              <a:rPr lang="en-US" sz="950" b="1" dirty="0">
                 <a:solidFill>
                   <a:srgbClr val="0F172A"/>
                 </a:solidFill>
@@ -4108,7 +4108,7 @@
               <a:buNone/>
             </a:pPr>
             <a:r>
-              <a:rPr lang="en-US" sz="900" dirty="0">
+              <a:rPr lang="en-US" sz="950" dirty="0">
                 <a:solidFill>
                   <a:srgbClr val="1E40AF"/>
                 </a:solidFill>
@@ -4116,14 +4116,14 @@
                 <a:ea typeface="Calibri" pitchFamily="34" charset="-122"/>
                 <a:cs typeface="Calibri" pitchFamily="34" charset="-120"/>
               </a:rPr>
-              <a:t>https://arpitthakor28.github.io/sms1/  (Installable mobile/desktop frontend)
+              <a:t>https://arpitthakor28.github.io/sms1/
 </a:t>
             </a:r>
             <a:pPr indent="0" marL="0">
               <a:buNone/>
             </a:pPr>
             <a:r>
-              <a:rPr lang="en-US" sz="900" b="1" dirty="0">
+              <a:rPr lang="en-US" sz="950" b="1" dirty="0">
                 <a:solidFill>
                   <a:srgbClr val="0F172A"/>
                 </a:solidFill>
@@ -4137,7 +4137,7 @@
               <a:buNone/>
             </a:pPr>
             <a:r>
-              <a:rPr lang="en-US" sz="900" dirty="0">
+              <a:rPr lang="en-US" sz="950" dirty="0">
                 <a:solidFill>
                   <a:srgbClr val="1E40AF"/>
                 </a:solidFill>
@@ -4145,14 +4145,14 @@
                 <a:ea typeface="Calibri" pitchFamily="34" charset="-122"/>
                 <a:cs typeface="Calibri" pitchFamily="34" charset="-120"/>
               </a:rPr>
-              <a:t>https://sms1-c9sj.onrender.com  (Spring Boot 3 + Java 21 container)
+              <a:t>https://sms1-c9sj.onrender.com
 </a:t>
             </a:r>
             <a:pPr indent="0" marL="0">
               <a:buNone/>
             </a:pPr>
             <a:r>
-              <a:rPr lang="en-US" sz="900" b="1" dirty="0">
+              <a:rPr lang="en-US" sz="950" b="1" dirty="0">
                 <a:solidFill>
                   <a:srgbClr val="0F172A"/>
                 </a:solidFill>
@@ -4166,7 +4166,7 @@
               <a:buNone/>
             </a:pPr>
             <a:r>
-              <a:rPr lang="en-US" sz="900" dirty="0">
+              <a:rPr lang="en-US" sz="950" dirty="0">
                 <a:solidFill>
                   <a:srgbClr val="1E40AF"/>
                 </a:solidFill>
@@ -4174,14 +4174,14 @@
                 <a:ea typeface="Calibri" pitchFamily="34" charset="-122"/>
                 <a:cs typeface="Calibri" pitchFamily="34" charset="-120"/>
               </a:rPr>
-              <a:t>https://sms1-c9sj.onrender.com/api/health  (Continuous uptime monitor)
+              <a:t>https://sms1-c9sj.onrender.com/api/health
 </a:t>
             </a:r>
             <a:pPr indent="0" marL="0">
               <a:buNone/>
             </a:pPr>
             <a:r>
-              <a:rPr lang="en-US" sz="900" b="1" dirty="0">
+              <a:rPr lang="en-US" sz="950" b="1" dirty="0">
                 <a:solidFill>
                   <a:srgbClr val="0F172A"/>
                 </a:solidFill>
@@ -4195,7 +4195,7 @@
               <a:buNone/>
             </a:pPr>
             <a:r>
-              <a:rPr lang="en-US" sz="900" dirty="0">
+              <a:rPr lang="en-US" sz="950" dirty="0">
                 <a:solidFill>
                   <a:srgbClr val="1E40AF"/>
                 </a:solidFill>
@@ -4203,9 +4203,9 @@
                 <a:ea typeface="Calibri" pitchFamily="34" charset="-122"/>
                 <a:cs typeface="Calibri" pitchFamily="34" charset="-120"/>
               </a:rPr>
-              <a:t>https://github.com/arpitthakor28/sms1  (Full-stack source with reports &amp; slides)</a:t>
-            </a:r>
-            <a:endParaRPr lang="en-US" sz="900" dirty="0"/>
+              <a:t>https://github.com/arpitthakor28/sms1</a:t>
+            </a:r>
+            <a:endParaRPr lang="en-US" sz="950" dirty="0"/>
           </a:p>
         </p:txBody>
       </p:sp>
@@ -7175,7 +7175,7 @@
       </p:sp>
       <p:pic>
         <p:nvPicPr>
-          <p:cNvPr id="15" name="Image 0" descr="D:\Projects\GATESYNC\screenshots\actual_gatesync_dashboard_dark.png">    </p:cNvPr>
+          <p:cNvPr id="15" name="Image 0" descr="D:\Projects\GATESYNC\screenshots\actual_gatesync_dashboard_white.png">    </p:cNvPr>
           <p:cNvPicPr>
             <a:picLocks noChangeAspect="1"/>
           </p:cNvPicPr>

</xml_diff>